<commit_message>
Refactor common worksheet, class notes config into YAML frontmatter snippet; assign reasonable dates
</commit_message>
<xml_diff>
--- a/assets/lecture-related/unit-01/01-introduction.pptx
+++ b/assets/lecture-related/unit-01/01-introduction.pptx
@@ -272,7 +272,7 @@
       </p:grpSpPr>
       <p:sp>
         <p:nvSpPr>
-          <p:cNvPr id="1425001758" name="Google Shape;3;n"/>
+          <p:cNvPr id="645119167" name="Google Shape;3;n"/>
           <p:cNvSpPr>
             <a:spLocks noChangeAspect="1" noGrp="1" noRot="1"/>
           </p:cNvSpPr>
@@ -323,7 +323,7 @@
       </p:sp>
       <p:sp>
         <p:nvSpPr>
-          <p:cNvPr id="1067073557" name="Google Shape;4;n"/>
+          <p:cNvPr id="1504698361" name="Google Shape;4;n"/>
           <p:cNvSpPr txBox="1">
             <a:spLocks noGrp="1"/>
           </p:cNvSpPr>
@@ -828,7 +828,7 @@
       </p:grpSpPr>
       <p:sp>
         <p:nvSpPr>
-          <p:cNvPr id="487994360" name="Google Shape;104;p2:notes"/>
+          <p:cNvPr id="96540802" name="Google Shape;104;p2:notes"/>
           <p:cNvSpPr>
             <a:spLocks noChangeAspect="1" noGrp="1" noRot="1"/>
           </p:cNvSpPr>
@@ -879,7 +879,7 @@
       </p:sp>
       <p:sp>
         <p:nvSpPr>
-          <p:cNvPr id="2063675751" name="Google Shape;105;p2:notes"/>
+          <p:cNvPr id="192943164" name="Google Shape;105;p2:notes"/>
           <p:cNvSpPr txBox="1">
             <a:spLocks noGrp="1"/>
           </p:cNvSpPr>
@@ -951,7 +951,7 @@
       </p:grpSpPr>
       <p:sp>
         <p:nvSpPr>
-          <p:cNvPr id="421618758" name="Slide Image Placeholder 1"/>
+          <p:cNvPr id="1199729400" name="Slide Image Placeholder 1"/>
           <p:cNvSpPr>
             <a:spLocks noChangeAspect="1" noGrp="1" noRot="1"/>
           </p:cNvSpPr>
@@ -963,7 +963,7 @@
       </p:sp>
       <p:sp>
         <p:nvSpPr>
-          <p:cNvPr id="1323619969" name="Notes Placeholder 2"/>
+          <p:cNvPr id="1088477055" name="Notes Placeholder 2"/>
           <p:cNvSpPr>
             <a:spLocks noGrp="1"/>
           </p:cNvSpPr>
@@ -985,7 +985,7 @@
       </p:sp>
       <p:sp>
         <p:nvSpPr>
-          <p:cNvPr id="1304725586" name="Slide Number Placeholder 3"/>
+          <p:cNvPr id="1248817045" name="Slide Number Placeholder 3"/>
           <p:cNvSpPr>
             <a:spLocks noGrp="1"/>
           </p:cNvSpPr>
@@ -1036,7 +1036,7 @@
       </p:grpSpPr>
       <p:sp>
         <p:nvSpPr>
-          <p:cNvPr id="52684385" name="Google Shape;512;g32a7fc5f463_1_0:notes"/>
+          <p:cNvPr id="1310566785" name="Google Shape;512;g32a7fc5f463_1_0:notes"/>
           <p:cNvSpPr>
             <a:spLocks noChangeAspect="1" noGrp="1" noRot="1"/>
           </p:cNvSpPr>
@@ -1087,7 +1087,7 @@
       </p:sp>
       <p:sp>
         <p:nvSpPr>
-          <p:cNvPr id="2030022610" name="Google Shape;513;g32a7fc5f463_1_0:notes"/>
+          <p:cNvPr id="868186716" name="Google Shape;513;g32a7fc5f463_1_0:notes"/>
           <p:cNvSpPr txBox="1">
             <a:spLocks noGrp="1"/>
           </p:cNvSpPr>
@@ -1163,7 +1163,7 @@
       </p:grpSpPr>
       <p:sp>
         <p:nvSpPr>
-          <p:cNvPr id="536242489" name="Google Shape;125;p4:notes"/>
+          <p:cNvPr id="2119921177" name="Google Shape;125;p4:notes"/>
           <p:cNvSpPr>
             <a:spLocks noChangeAspect="1" noGrp="1" noRot="1"/>
           </p:cNvSpPr>
@@ -1214,7 +1214,7 @@
       </p:sp>
       <p:sp>
         <p:nvSpPr>
-          <p:cNvPr id="1587239419" name="Google Shape;126;p4:notes"/>
+          <p:cNvPr id="814200063" name="Google Shape;126;p4:notes"/>
           <p:cNvSpPr txBox="1">
             <a:spLocks noGrp="1"/>
           </p:cNvSpPr>
@@ -1286,7 +1286,7 @@
       </p:grpSpPr>
       <p:sp>
         <p:nvSpPr>
-          <p:cNvPr id="1518098554" name="Google Shape;132;p5:notes"/>
+          <p:cNvPr id="1899168447" name="Google Shape;132;p5:notes"/>
           <p:cNvSpPr>
             <a:spLocks noChangeAspect="1" noGrp="1" noRot="1"/>
           </p:cNvSpPr>
@@ -1337,7 +1337,7 @@
       </p:sp>
       <p:sp>
         <p:nvSpPr>
-          <p:cNvPr id="1626137943" name="Google Shape;133;p5:notes"/>
+          <p:cNvPr id="634762904" name="Google Shape;133;p5:notes"/>
           <p:cNvSpPr txBox="1">
             <a:spLocks noGrp="1"/>
           </p:cNvSpPr>
@@ -1409,7 +1409,7 @@
       </p:grpSpPr>
       <p:sp>
         <p:nvSpPr>
-          <p:cNvPr id="325776843" name="Google Shape;139;p6:notes"/>
+          <p:cNvPr id="287007058" name="Google Shape;139;p6:notes"/>
           <p:cNvSpPr>
             <a:spLocks noChangeAspect="1" noGrp="1" noRot="1"/>
           </p:cNvSpPr>
@@ -1460,7 +1460,7 @@
       </p:sp>
       <p:sp>
         <p:nvSpPr>
-          <p:cNvPr id="1305469615" name="Google Shape;140;p6:notes"/>
+          <p:cNvPr id="2012399709" name="Google Shape;140;p6:notes"/>
           <p:cNvSpPr txBox="1">
             <a:spLocks noGrp="1"/>
           </p:cNvSpPr>
@@ -1507,7 +1507,7 @@
       </p:sp>
       <p:sp>
         <p:nvSpPr>
-          <p:cNvPr id="1393772922" name="Google Shape;141;p6:notes"/>
+          <p:cNvPr id="1398864431" name="Google Shape;141;p6:notes"/>
           <p:cNvSpPr txBox="1">
             <a:spLocks noGrp="1"/>
           </p:cNvSpPr>
@@ -1601,7 +1601,7 @@
       </p:grpSpPr>
       <p:sp>
         <p:nvSpPr>
-          <p:cNvPr id="1118602904" name="Google Shape;175;g320ca67c64f_0_233:notes"/>
+          <p:cNvPr id="1858720847" name="Google Shape;175;g320ca67c64f_0_233:notes"/>
           <p:cNvSpPr>
             <a:spLocks noChangeAspect="1" noGrp="1" noRot="1"/>
           </p:cNvSpPr>
@@ -1642,7 +1642,7 @@
       </p:sp>
       <p:sp>
         <p:nvSpPr>
-          <p:cNvPr id="1669562858" name="Google Shape;176;g320ca67c64f_0_233:notes"/>
+          <p:cNvPr id="1352010796" name="Google Shape;176;g320ca67c64f_0_233:notes"/>
           <p:cNvSpPr txBox="1">
             <a:spLocks noGrp="1"/>
           </p:cNvSpPr>
@@ -1706,7 +1706,7 @@
       </p:grpSpPr>
       <p:sp>
         <p:nvSpPr>
-          <p:cNvPr id="105669943" name="Google Shape;205;g320ca67c64f_0_259:notes"/>
+          <p:cNvPr id="1726319844" name="Google Shape;205;g320ca67c64f_0_259:notes"/>
           <p:cNvSpPr>
             <a:spLocks noChangeAspect="1" noGrp="1" noRot="1"/>
           </p:cNvSpPr>
@@ -1747,7 +1747,7 @@
       </p:sp>
       <p:sp>
         <p:nvSpPr>
-          <p:cNvPr id="1518886719" name="Google Shape;206;g320ca67c64f_0_259:notes"/>
+          <p:cNvPr id="174326149" name="Google Shape;206;g320ca67c64f_0_259:notes"/>
           <p:cNvSpPr txBox="1">
             <a:spLocks noGrp="1"/>
           </p:cNvSpPr>
@@ -1811,7 +1811,7 @@
       </p:grpSpPr>
       <p:sp>
         <p:nvSpPr>
-          <p:cNvPr id="912600508" name="Google Shape;212;g320ca67c64f_0_265:notes"/>
+          <p:cNvPr id="1589215799" name="Google Shape;212;g320ca67c64f_0_265:notes"/>
           <p:cNvSpPr>
             <a:spLocks noChangeAspect="1" noGrp="1" noRot="1"/>
           </p:cNvSpPr>
@@ -1852,7 +1852,7 @@
       </p:sp>
       <p:sp>
         <p:nvSpPr>
-          <p:cNvPr id="921627833" name="Google Shape;213;g320ca67c64f_0_265:notes"/>
+          <p:cNvPr id="489260511" name="Google Shape;213;g320ca67c64f_0_265:notes"/>
           <p:cNvSpPr txBox="1">
             <a:spLocks noGrp="1"/>
           </p:cNvSpPr>
@@ -1916,7 +1916,7 @@
       </p:grpSpPr>
       <p:sp>
         <p:nvSpPr>
-          <p:cNvPr id="302069586" name="Google Shape;174;g2f6e17132a5_0_85:notes"/>
+          <p:cNvPr id="576739461" name="Google Shape;174;g2f6e17132a5_0_85:notes"/>
           <p:cNvSpPr>
             <a:spLocks noChangeAspect="1" noGrp="1" noRot="1"/>
           </p:cNvSpPr>
@@ -1957,7 +1957,7 @@
       </p:sp>
       <p:sp>
         <p:nvSpPr>
-          <p:cNvPr id="1453689169" name="Google Shape;175;g2f6e17132a5_0_85:notes"/>
+          <p:cNvPr id="300480531" name="Google Shape;175;g2f6e17132a5_0_85:notes"/>
           <p:cNvSpPr txBox="1">
             <a:spLocks noGrp="1"/>
           </p:cNvSpPr>
@@ -2021,7 +2021,7 @@
       </p:grpSpPr>
       <p:sp>
         <p:nvSpPr>
-          <p:cNvPr id="251021677" name="Slide Image Placeholder 1"/>
+          <p:cNvPr id="1295512348" name="Slide Image Placeholder 1"/>
           <p:cNvSpPr>
             <a:spLocks noChangeAspect="1" noGrp="1" noRot="1"/>
           </p:cNvSpPr>
@@ -2033,7 +2033,7 @@
       </p:sp>
       <p:sp>
         <p:nvSpPr>
-          <p:cNvPr id="1297093787" name="Notes Placeholder 2"/>
+          <p:cNvPr id="735606424" name="Notes Placeholder 2"/>
           <p:cNvSpPr>
             <a:spLocks noGrp="1"/>
           </p:cNvSpPr>
@@ -2055,7 +2055,7 @@
       </p:sp>
       <p:sp>
         <p:nvSpPr>
-          <p:cNvPr id="1828948971" name="Slide Number Placeholder 3"/>
+          <p:cNvPr id="1463322141" name="Slide Number Placeholder 3"/>
           <p:cNvSpPr>
             <a:spLocks noGrp="1"/>
           </p:cNvSpPr>
@@ -2106,7 +2106,7 @@
       </p:grpSpPr>
       <p:sp>
         <p:nvSpPr>
-          <p:cNvPr id="814708721" name="Google Shape;10;p50"/>
+          <p:cNvPr id="340512768" name="Google Shape;10;p50"/>
           <p:cNvSpPr txBox="1">
             <a:spLocks noGrp="1"/>
           </p:cNvSpPr>
@@ -2269,7 +2269,7 @@
       </p:sp>
       <p:sp>
         <p:nvSpPr>
-          <p:cNvPr id="1181373077" name="Google Shape;11;p50"/>
+          <p:cNvPr id="1507177798" name="Google Shape;11;p50"/>
           <p:cNvSpPr txBox="1">
             <a:spLocks noGrp="1"/>
           </p:cNvSpPr>
@@ -2432,7 +2432,7 @@
       </p:sp>
       <p:sp>
         <p:nvSpPr>
-          <p:cNvPr id="1237459257" name="Google Shape;12;p50"/>
+          <p:cNvPr id="1740797166" name="Google Shape;12;p50"/>
           <p:cNvSpPr txBox="1">
             <a:spLocks noGrp="1"/>
           </p:cNvSpPr>
@@ -2730,7 +2730,7 @@
       </p:grpSpPr>
       <p:sp>
         <p:nvSpPr>
-          <p:cNvPr id="1912442773" name="Google Shape;46;p60"/>
+          <p:cNvPr id="378190620" name="Google Shape;46;p60"/>
           <p:cNvSpPr txBox="1">
             <a:spLocks noGrp="1"/>
           </p:cNvSpPr>
@@ -2893,7 +2893,7 @@
       </p:sp>
       <p:sp>
         <p:nvSpPr>
-          <p:cNvPr id="358675727" name="Google Shape;47;p60"/>
+          <p:cNvPr id="478862617" name="Google Shape;47;p60"/>
           <p:cNvSpPr txBox="1">
             <a:spLocks noGrp="1"/>
           </p:cNvSpPr>
@@ -3056,7 +3056,7 @@
       </p:sp>
       <p:sp>
         <p:nvSpPr>
-          <p:cNvPr id="374068796" name="Google Shape;48;p60"/>
+          <p:cNvPr id="2070721061" name="Google Shape;48;p60"/>
           <p:cNvSpPr txBox="1"/>
           <p:nvPr/>
         </p:nvSpPr>
@@ -3121,7 +3121,7 @@
       </p:sp>
       <p:sp>
         <p:nvSpPr>
-          <p:cNvPr id="1657656021" name="Google Shape;49;p60"/>
+          <p:cNvPr id="1929093251" name="Google Shape;49;p60"/>
           <p:cNvSpPr txBox="1">
             <a:spLocks noGrp="1"/>
           </p:cNvSpPr>
@@ -3426,7 +3426,7 @@
       </p:grpSpPr>
       <p:sp>
         <p:nvSpPr>
-          <p:cNvPr id="415398943" name="Google Shape;55;g320ca67c64f_0_413"/>
+          <p:cNvPr id="634140464" name="Google Shape;55;g320ca67c64f_0_413"/>
           <p:cNvSpPr txBox="1">
             <a:spLocks noGrp="1"/>
           </p:cNvSpPr>
@@ -3558,7 +3558,7 @@
       </p:sp>
       <p:sp>
         <p:nvSpPr>
-          <p:cNvPr id="1581640630" name="Google Shape;56;g320ca67c64f_0_413"/>
+          <p:cNvPr id="1019801480" name="Google Shape;56;g320ca67c64f_0_413"/>
           <p:cNvSpPr txBox="1">
             <a:spLocks noGrp="1"/>
           </p:cNvSpPr>
@@ -3762,7 +3762,7 @@
       </p:sp>
       <p:sp>
         <p:nvSpPr>
-          <p:cNvPr id="226468705" name="Google Shape;57;g320ca67c64f_0_413"/>
+          <p:cNvPr id="1492115319" name="Google Shape;57;g320ca67c64f_0_413"/>
           <p:cNvSpPr txBox="1">
             <a:spLocks noGrp="1"/>
           </p:cNvSpPr>
@@ -3937,7 +3937,7 @@
       </p:grpSpPr>
       <p:sp>
         <p:nvSpPr>
-          <p:cNvPr id="1659398660" name="Google Shape;59;g320ca67c64f_0_417"/>
+          <p:cNvPr id="1078380983" name="Google Shape;59;g320ca67c64f_0_417"/>
           <p:cNvSpPr txBox="1">
             <a:spLocks noGrp="1"/>
           </p:cNvSpPr>
@@ -4069,7 +4069,7 @@
       </p:sp>
       <p:sp>
         <p:nvSpPr>
-          <p:cNvPr id="1087281927" name="Google Shape;60;g320ca67c64f_0_417"/>
+          <p:cNvPr id="1194902754" name="Google Shape;60;g320ca67c64f_0_417"/>
           <p:cNvSpPr txBox="1">
             <a:spLocks noGrp="1"/>
           </p:cNvSpPr>
@@ -4237,7 +4237,7 @@
       </p:grpSpPr>
       <p:sp>
         <p:nvSpPr>
-          <p:cNvPr id="1925676178" name="Google Shape;62;g320ca67c64f_0_420"/>
+          <p:cNvPr id="1628372407" name="Google Shape;62;g320ca67c64f_0_420"/>
           <p:cNvSpPr txBox="1">
             <a:spLocks noGrp="1"/>
           </p:cNvSpPr>
@@ -4369,7 +4369,7 @@
       </p:sp>
       <p:sp>
         <p:nvSpPr>
-          <p:cNvPr id="930224330" name="Google Shape;63;g320ca67c64f_0_420"/>
+          <p:cNvPr id="1564390426" name="Google Shape;63;g320ca67c64f_0_420"/>
           <p:cNvSpPr txBox="1">
             <a:spLocks noGrp="1"/>
           </p:cNvSpPr>
@@ -4501,7 +4501,7 @@
       </p:sp>
       <p:sp>
         <p:nvSpPr>
-          <p:cNvPr id="1371753292" name="Google Shape;64;g320ca67c64f_0_420"/>
+          <p:cNvPr id="1069200080" name="Google Shape;64;g320ca67c64f_0_420"/>
           <p:cNvSpPr txBox="1">
             <a:spLocks noGrp="1"/>
           </p:cNvSpPr>
@@ -4606,7 +4606,7 @@
       </p:grpSpPr>
       <p:sp>
         <p:nvSpPr>
-          <p:cNvPr id="256725260" name="Google Shape;66;g320ca67c64f_0_424"/>
+          <p:cNvPr id="1161195623" name="Google Shape;66;g320ca67c64f_0_424"/>
           <p:cNvSpPr txBox="1">
             <a:spLocks noGrp="1"/>
           </p:cNvSpPr>
@@ -4738,7 +4738,7 @@
       </p:sp>
       <p:sp>
         <p:nvSpPr>
-          <p:cNvPr id="1370955283" name="Google Shape;67;g320ca67c64f_0_424"/>
+          <p:cNvPr id="1933625847" name="Google Shape;67;g320ca67c64f_0_424"/>
           <p:cNvSpPr txBox="1">
             <a:spLocks noGrp="1"/>
           </p:cNvSpPr>
@@ -4870,7 +4870,7 @@
       </p:sp>
       <p:sp>
         <p:nvSpPr>
-          <p:cNvPr id="99618760" name="Google Shape;68;g320ca67c64f_0_424"/>
+          <p:cNvPr id="983146088" name="Google Shape;68;g320ca67c64f_0_424"/>
           <p:cNvSpPr txBox="1">
             <a:spLocks noGrp="1"/>
           </p:cNvSpPr>
@@ -5038,7 +5038,7 @@
       </p:grpSpPr>
       <p:sp>
         <p:nvSpPr>
-          <p:cNvPr id="1129999272" name="Google Shape;70;g320ca67c64f_0_428"/>
+          <p:cNvPr id="8312537" name="Google Shape;70;g320ca67c64f_0_428"/>
           <p:cNvSpPr txBox="1">
             <a:spLocks noGrp="1"/>
           </p:cNvSpPr>
@@ -5170,7 +5170,7 @@
       </p:sp>
       <p:sp>
         <p:nvSpPr>
-          <p:cNvPr id="2029277916" name="Google Shape;71;g320ca67c64f_0_428"/>
+          <p:cNvPr id="1053217533" name="Google Shape;71;g320ca67c64f_0_428"/>
           <p:cNvSpPr txBox="1">
             <a:spLocks noGrp="1"/>
           </p:cNvSpPr>
@@ -5302,7 +5302,7 @@
       </p:sp>
       <p:sp>
         <p:nvSpPr>
-          <p:cNvPr id="1748525589" name="Google Shape;72;g320ca67c64f_0_428"/>
+          <p:cNvPr id="1803092274" name="Google Shape;72;g320ca67c64f_0_428"/>
           <p:cNvSpPr txBox="1"/>
           <p:nvPr/>
         </p:nvSpPr>
@@ -5359,7 +5359,7 @@
       </p:sp>
       <p:sp>
         <p:nvSpPr>
-          <p:cNvPr id="1458670458" name="Google Shape;73;g320ca67c64f_0_428"/>
+          <p:cNvPr id="2088314870" name="Google Shape;73;g320ca67c64f_0_428"/>
           <p:cNvSpPr txBox="1">
             <a:spLocks noGrp="1"/>
           </p:cNvSpPr>
@@ -5534,7 +5534,7 @@
       </p:grpSpPr>
       <p:sp>
         <p:nvSpPr>
-          <p:cNvPr id="381010814" name="Google Shape;75;g320ca67c64f_0_433"/>
+          <p:cNvPr id="996443173" name="Google Shape;75;g320ca67c64f_0_433"/>
           <p:cNvSpPr txBox="1">
             <a:spLocks noGrp="1"/>
           </p:cNvSpPr>
@@ -5666,7 +5666,7 @@
       </p:sp>
       <p:sp>
         <p:nvSpPr>
-          <p:cNvPr id="1412834401" name="Google Shape;76;g320ca67c64f_0_433"/>
+          <p:cNvPr id="1115399814" name="Google Shape;76;g320ca67c64f_0_433"/>
           <p:cNvSpPr txBox="1">
             <a:spLocks noGrp="1"/>
           </p:cNvSpPr>
@@ -5841,7 +5841,7 @@
       </p:grpSpPr>
       <p:sp>
         <p:nvSpPr>
-          <p:cNvPr id="1869691426" name="Google Shape;78;g320ca67c64f_0_436"/>
+          <p:cNvPr id="67109605" name="Google Shape;78;g320ca67c64f_0_436"/>
           <p:cNvSpPr txBox="1">
             <a:spLocks noGrp="1"/>
           </p:cNvSpPr>
@@ -5888,7 +5888,7 @@
       </p:sp>
       <p:sp>
         <p:nvSpPr>
-          <p:cNvPr id="1620382901" name="Google Shape;79;g320ca67c64f_0_436"/>
+          <p:cNvPr id="516413850" name="Google Shape;79;g320ca67c64f_0_436"/>
           <p:cNvSpPr txBox="1">
             <a:spLocks noGrp="1"/>
           </p:cNvSpPr>
@@ -6063,7 +6063,7 @@
       </p:grpSpPr>
       <p:sp>
         <p:nvSpPr>
-          <p:cNvPr id="362143709" name="Google Shape;81;g320ca67c64f_0_439"/>
+          <p:cNvPr id="855284430" name="Google Shape;81;g320ca67c64f_0_439"/>
           <p:cNvSpPr txBox="1">
             <a:spLocks noGrp="1"/>
           </p:cNvSpPr>
@@ -6231,7 +6231,7 @@
       </p:grpSpPr>
       <p:sp>
         <p:nvSpPr>
-          <p:cNvPr id="481983044" name="Google Shape;83;g320ca67c64f_0_441"/>
+          <p:cNvPr id="1011276009" name="Google Shape;83;g320ca67c64f_0_441"/>
           <p:cNvSpPr txBox="1">
             <a:spLocks noGrp="1"/>
           </p:cNvSpPr>
@@ -6363,7 +6363,7 @@
       </p:sp>
       <p:sp>
         <p:nvSpPr>
-          <p:cNvPr id="260310775" name="Google Shape;84;g320ca67c64f_0_441"/>
+          <p:cNvPr id="1293816692" name="Google Shape;84;g320ca67c64f_0_441"/>
           <p:cNvSpPr txBox="1">
             <a:spLocks noGrp="1"/>
           </p:cNvSpPr>
@@ -6495,7 +6495,7 @@
       </p:sp>
       <p:sp>
         <p:nvSpPr>
-          <p:cNvPr id="670450001" name="Google Shape;85;g320ca67c64f_0_441"/>
+          <p:cNvPr id="1994327974" name="Google Shape;85;g320ca67c64f_0_441"/>
           <p:cNvSpPr txBox="1">
             <a:spLocks noGrp="1"/>
           </p:cNvSpPr>
@@ -6607,7 +6607,7 @@
       </p:grpSpPr>
       <p:sp>
         <p:nvSpPr>
-          <p:cNvPr id="1303193589" name="Google Shape;14;p51"/>
+          <p:cNvPr id="1201955558" name="Google Shape;14;p51"/>
           <p:cNvSpPr txBox="1">
             <a:spLocks noGrp="1"/>
           </p:cNvSpPr>
@@ -6770,7 +6770,7 @@
       </p:sp>
       <p:sp>
         <p:nvSpPr>
-          <p:cNvPr id="363343883" name="Google Shape;15;p51"/>
+          <p:cNvPr id="107388525" name="Google Shape;15;p51"/>
           <p:cNvSpPr txBox="1">
             <a:spLocks noGrp="1"/>
           </p:cNvSpPr>
@@ -6978,7 +6978,7 @@
       </p:sp>
       <p:sp>
         <p:nvSpPr>
-          <p:cNvPr id="1063340785" name="Google Shape;16;p51"/>
+          <p:cNvPr id="309505366" name="Google Shape;16;p51"/>
           <p:cNvSpPr txBox="1">
             <a:spLocks noGrp="1"/>
           </p:cNvSpPr>
@@ -7276,7 +7276,7 @@
       </p:grpSpPr>
       <p:sp>
         <p:nvSpPr>
-          <p:cNvPr id="1677914314" name="Google Shape;91;g320ca67c64f_0_449"/>
+          <p:cNvPr id="439670839" name="Google Shape;91;g320ca67c64f_0_449"/>
           <p:cNvSpPr txBox="1">
             <a:spLocks noGrp="1"/>
           </p:cNvSpPr>
@@ -7408,7 +7408,7 @@
       </p:sp>
       <p:sp>
         <p:nvSpPr>
-          <p:cNvPr id="1375218626" name="Google Shape;92;g320ca67c64f_0_449"/>
+          <p:cNvPr id="72782019" name="Google Shape;92;g320ca67c64f_0_449"/>
           <p:cNvSpPr txBox="1">
             <a:spLocks noGrp="1"/>
           </p:cNvSpPr>
@@ -7540,7 +7540,7 @@
       </p:sp>
       <p:sp>
         <p:nvSpPr>
-          <p:cNvPr id="1233415897" name="Google Shape;93;g320ca67c64f_0_449"/>
+          <p:cNvPr id="1457560583" name="Google Shape;93;g320ca67c64f_0_449"/>
           <p:cNvSpPr txBox="1"/>
           <p:nvPr/>
         </p:nvSpPr>
@@ -7597,7 +7597,7 @@
       </p:sp>
       <p:sp>
         <p:nvSpPr>
-          <p:cNvPr id="491691733" name="Google Shape;94;g320ca67c64f_0_449"/>
+          <p:cNvPr id="714154883" name="Google Shape;94;g320ca67c64f_0_449"/>
           <p:cNvSpPr txBox="1">
             <a:spLocks noGrp="1"/>
           </p:cNvSpPr>
@@ -7772,7 +7772,7 @@
       </p:grpSpPr>
       <p:sp>
         <p:nvSpPr>
-          <p:cNvPr id="1550179916" name="Google Shape;10;p2"/>
+          <p:cNvPr id="314931768" name="Google Shape;10;p2"/>
           <p:cNvSpPr txBox="1">
             <a:spLocks noGrp="1"/>
           </p:cNvSpPr>
@@ -7904,7 +7904,7 @@
       </p:sp>
       <p:sp>
         <p:nvSpPr>
-          <p:cNvPr id="579463067" name="Google Shape;11;p2"/>
+          <p:cNvPr id="1515472117" name="Google Shape;11;p2"/>
           <p:cNvSpPr txBox="1">
             <a:spLocks noGrp="1"/>
           </p:cNvSpPr>
@@ -8108,7 +8108,7 @@
       </p:sp>
       <p:sp>
         <p:nvSpPr>
-          <p:cNvPr id="1890773952" name="Google Shape;12;p2"/>
+          <p:cNvPr id="1259889137" name="Google Shape;12;p2"/>
           <p:cNvSpPr txBox="1">
             <a:spLocks noGrp="1"/>
           </p:cNvSpPr>
@@ -8283,7 +8283,7 @@
       </p:grpSpPr>
       <p:sp>
         <p:nvSpPr>
-          <p:cNvPr id="2139922709" name="Google Shape;14;p3"/>
+          <p:cNvPr id="252802716" name="Google Shape;14;p3"/>
           <p:cNvSpPr txBox="1">
             <a:spLocks noGrp="1"/>
           </p:cNvSpPr>
@@ -8415,7 +8415,7 @@
       </p:sp>
       <p:sp>
         <p:nvSpPr>
-          <p:cNvPr id="502031955" name="Google Shape;15;p3"/>
+          <p:cNvPr id="750257776" name="Google Shape;15;p3"/>
           <p:cNvSpPr txBox="1">
             <a:spLocks noGrp="1"/>
           </p:cNvSpPr>
@@ -8583,7 +8583,7 @@
       </p:grpSpPr>
       <p:sp>
         <p:nvSpPr>
-          <p:cNvPr id="632781383" name="Google Shape;17;p4"/>
+          <p:cNvPr id="1793706499" name="Google Shape;17;p4"/>
           <p:cNvSpPr txBox="1">
             <a:spLocks noGrp="1"/>
           </p:cNvSpPr>
@@ -8715,7 +8715,7 @@
       </p:sp>
       <p:sp>
         <p:nvSpPr>
-          <p:cNvPr id="1678109193" name="Google Shape;18;p4"/>
+          <p:cNvPr id="1671461080" name="Google Shape;18;p4"/>
           <p:cNvSpPr txBox="1">
             <a:spLocks noGrp="1"/>
           </p:cNvSpPr>
@@ -8847,7 +8847,7 @@
       </p:sp>
       <p:sp>
         <p:nvSpPr>
-          <p:cNvPr id="1498631566" name="Google Shape;19;p4"/>
+          <p:cNvPr id="2095607801" name="Google Shape;19;p4"/>
           <p:cNvSpPr txBox="1">
             <a:spLocks noGrp="1"/>
           </p:cNvSpPr>
@@ -8952,7 +8952,7 @@
       </p:grpSpPr>
       <p:sp>
         <p:nvSpPr>
-          <p:cNvPr id="868026931" name="Google Shape;21;p5"/>
+          <p:cNvPr id="362642272" name="Google Shape;21;p5"/>
           <p:cNvSpPr txBox="1">
             <a:spLocks noGrp="1"/>
           </p:cNvSpPr>
@@ -9084,7 +9084,7 @@
       </p:sp>
       <p:sp>
         <p:nvSpPr>
-          <p:cNvPr id="1127926154" name="Google Shape;22;p5"/>
+          <p:cNvPr id="650508756" name="Google Shape;22;p5"/>
           <p:cNvSpPr txBox="1">
             <a:spLocks noGrp="1"/>
           </p:cNvSpPr>
@@ -9216,7 +9216,7 @@
       </p:sp>
       <p:sp>
         <p:nvSpPr>
-          <p:cNvPr id="1432904548" name="Google Shape;23;p5"/>
+          <p:cNvPr id="1461309970" name="Google Shape;23;p5"/>
           <p:cNvSpPr txBox="1">
             <a:spLocks noGrp="1"/>
           </p:cNvSpPr>
@@ -9384,7 +9384,7 @@
       </p:grpSpPr>
       <p:sp>
         <p:nvSpPr>
-          <p:cNvPr id="912987006" name="Google Shape;25;p6"/>
+          <p:cNvPr id="1699145669" name="Google Shape;25;p6"/>
           <p:cNvSpPr txBox="1">
             <a:spLocks noGrp="1"/>
           </p:cNvSpPr>
@@ -9516,7 +9516,7 @@
       </p:sp>
       <p:sp>
         <p:nvSpPr>
-          <p:cNvPr id="797579661" name="Google Shape;26;p6"/>
+          <p:cNvPr id="833297422" name="Google Shape;26;p6"/>
           <p:cNvSpPr txBox="1">
             <a:spLocks noGrp="1"/>
           </p:cNvSpPr>
@@ -9648,7 +9648,7 @@
       </p:sp>
       <p:sp>
         <p:nvSpPr>
-          <p:cNvPr id="1076640688" name="Google Shape;27;p6"/>
+          <p:cNvPr id="352341168" name="Google Shape;27;p6"/>
           <p:cNvSpPr txBox="1"/>
           <p:nvPr/>
         </p:nvSpPr>
@@ -9705,7 +9705,7 @@
       </p:sp>
       <p:sp>
         <p:nvSpPr>
-          <p:cNvPr id="1002012809" name="Google Shape;28;p6"/>
+          <p:cNvPr id="595301058" name="Google Shape;28;p6"/>
           <p:cNvSpPr txBox="1">
             <a:spLocks noGrp="1"/>
           </p:cNvSpPr>
@@ -9880,7 +9880,7 @@
       </p:grpSpPr>
       <p:sp>
         <p:nvSpPr>
-          <p:cNvPr id="1339255870" name="Google Shape;30;p7"/>
+          <p:cNvPr id="481574489" name="Google Shape;30;p7"/>
           <p:cNvSpPr txBox="1">
             <a:spLocks noGrp="1"/>
           </p:cNvSpPr>
@@ -10012,7 +10012,7 @@
       </p:sp>
       <p:sp>
         <p:nvSpPr>
-          <p:cNvPr id="1893338594" name="Google Shape;31;p7"/>
+          <p:cNvPr id="848062365" name="Google Shape;31;p7"/>
           <p:cNvSpPr txBox="1">
             <a:spLocks noGrp="1"/>
           </p:cNvSpPr>
@@ -10187,7 +10187,7 @@
       </p:grpSpPr>
       <p:sp>
         <p:nvSpPr>
-          <p:cNvPr id="1680955460" name="Google Shape;33;p8"/>
+          <p:cNvPr id="1085534843" name="Google Shape;33;p8"/>
           <p:cNvSpPr txBox="1">
             <a:spLocks noGrp="1"/>
           </p:cNvSpPr>
@@ -10234,7 +10234,7 @@
       </p:sp>
       <p:sp>
         <p:nvSpPr>
-          <p:cNvPr id="271968667" name="Google Shape;34;p8"/>
+          <p:cNvPr id="169369617" name="Google Shape;34;p8"/>
           <p:cNvSpPr txBox="1">
             <a:spLocks noGrp="1"/>
           </p:cNvSpPr>
@@ -10409,7 +10409,7 @@
       </p:grpSpPr>
       <p:sp>
         <p:nvSpPr>
-          <p:cNvPr id="1126429506" name="Google Shape;36;p9"/>
+          <p:cNvPr id="1136065248" name="Google Shape;36;p9"/>
           <p:cNvSpPr txBox="1">
             <a:spLocks noGrp="1"/>
           </p:cNvSpPr>
@@ -10577,7 +10577,7 @@
       </p:grpSpPr>
       <p:sp>
         <p:nvSpPr>
-          <p:cNvPr id="1255611221" name="Google Shape;38;p10"/>
+          <p:cNvPr id="15596857" name="Google Shape;38;p10"/>
           <p:cNvSpPr txBox="1">
             <a:spLocks noGrp="1"/>
           </p:cNvSpPr>
@@ -10709,7 +10709,7 @@
       </p:sp>
       <p:sp>
         <p:nvSpPr>
-          <p:cNvPr id="795082382" name="Google Shape;39;p10"/>
+          <p:cNvPr id="687887569" name="Google Shape;39;p10"/>
           <p:cNvSpPr txBox="1">
             <a:spLocks noGrp="1"/>
           </p:cNvSpPr>
@@ -10841,7 +10841,7 @@
       </p:sp>
       <p:sp>
         <p:nvSpPr>
-          <p:cNvPr id="1251715646" name="Google Shape;40;p10"/>
+          <p:cNvPr id="1411760354" name="Google Shape;40;p10"/>
           <p:cNvSpPr txBox="1">
             <a:spLocks noGrp="1"/>
           </p:cNvSpPr>
@@ -10946,7 +10946,7 @@
       </p:grpSpPr>
       <p:sp>
         <p:nvSpPr>
-          <p:cNvPr id="395926809" name="Google Shape;18;p52"/>
+          <p:cNvPr id="433860829" name="Google Shape;18;p52"/>
           <p:cNvSpPr txBox="1">
             <a:spLocks noGrp="1"/>
           </p:cNvSpPr>
@@ -11109,7 +11109,7 @@
       </p:sp>
       <p:sp>
         <p:nvSpPr>
-          <p:cNvPr id="1876326890" name="Google Shape;19;p52"/>
+          <p:cNvPr id="1561749454" name="Google Shape;19;p52"/>
           <p:cNvSpPr txBox="1">
             <a:spLocks noGrp="1"/>
           </p:cNvSpPr>
@@ -11272,7 +11272,7 @@
       </p:sp>
       <p:sp>
         <p:nvSpPr>
-          <p:cNvPr id="97575985" name="Google Shape;20;p52"/>
+          <p:cNvPr id="377962728" name="Google Shape;20;p52"/>
           <p:cNvSpPr txBox="1">
             <a:spLocks noGrp="1"/>
           </p:cNvSpPr>
@@ -11570,7 +11570,7 @@
       </p:grpSpPr>
       <p:sp>
         <p:nvSpPr>
-          <p:cNvPr id="1892080386" name="Google Shape;46;p12"/>
+          <p:cNvPr id="1804638791" name="Google Shape;46;p12"/>
           <p:cNvSpPr txBox="1">
             <a:spLocks noGrp="1"/>
           </p:cNvSpPr>
@@ -11702,7 +11702,7 @@
       </p:sp>
       <p:sp>
         <p:nvSpPr>
-          <p:cNvPr id="1564117149" name="Google Shape;47;p12"/>
+          <p:cNvPr id="218249089" name="Google Shape;47;p12"/>
           <p:cNvSpPr txBox="1">
             <a:spLocks noGrp="1"/>
           </p:cNvSpPr>
@@ -11834,7 +11834,7 @@
       </p:sp>
       <p:sp>
         <p:nvSpPr>
-          <p:cNvPr id="1274484304" name="Google Shape;48;p12"/>
+          <p:cNvPr id="1564581848" name="Google Shape;48;p12"/>
           <p:cNvSpPr txBox="1"/>
           <p:nvPr/>
         </p:nvSpPr>
@@ -11891,7 +11891,7 @@
       </p:sp>
       <p:sp>
         <p:nvSpPr>
-          <p:cNvPr id="639337732" name="Google Shape;49;p12"/>
+          <p:cNvPr id="1359553452" name="Google Shape;49;p12"/>
           <p:cNvSpPr txBox="1">
             <a:spLocks noGrp="1"/>
           </p:cNvSpPr>
@@ -12069,7 +12069,7 @@
       </p:grpSpPr>
       <p:sp>
         <p:nvSpPr>
-          <p:cNvPr id="512622946" name="Rectangle 6"/>
+          <p:cNvPr id="1523191116" name="Rectangle 6"/>
           <p:cNvSpPr/>
           <p:nvPr userDrawn="1"/>
         </p:nvSpPr>
@@ -12093,7 +12093,7 @@
       </p:sp>
       <p:sp>
         <p:nvSpPr>
-          <p:cNvPr id="2081431194" name="Rectangle 16"/>
+          <p:cNvPr id="1699497960" name="Rectangle 16"/>
           <p:cNvSpPr/>
           <p:nvPr userDrawn="1"/>
         </p:nvSpPr>
@@ -12117,7 +12117,7 @@
       </p:sp>
       <p:sp>
         <p:nvSpPr>
-          <p:cNvPr id="1353087677" name="Rectangle 18"/>
+          <p:cNvPr id="2008044015" name="Rectangle 18"/>
           <p:cNvSpPr/>
           <p:nvPr userDrawn="1"/>
         </p:nvSpPr>
@@ -12141,7 +12141,7 @@
       </p:sp>
       <p:sp>
         <p:nvSpPr>
-          <p:cNvPr id="946551818" name="Rectangle 19"/>
+          <p:cNvPr id="1099363110" name="Rectangle 19"/>
           <p:cNvSpPr/>
           <p:nvPr userDrawn="1"/>
         </p:nvSpPr>
@@ -12165,7 +12165,7 @@
       </p:sp>
       <p:sp>
         <p:nvSpPr>
-          <p:cNvPr id="1264230988" name="Rectangle 21"/>
+          <p:cNvPr id="19659267" name="Rectangle 21"/>
           <p:cNvSpPr/>
           <p:nvPr userDrawn="1"/>
         </p:nvSpPr>
@@ -12189,7 +12189,7 @@
       </p:sp>
       <p:sp>
         <p:nvSpPr>
-          <p:cNvPr id="761759559" name="Rectangle 22"/>
+          <p:cNvPr id="330368108" name="Rectangle 22"/>
           <p:cNvSpPr/>
           <p:nvPr userDrawn="1"/>
         </p:nvSpPr>
@@ -12213,7 +12213,7 @@
       </p:sp>
       <p:sp>
         <p:nvSpPr>
-          <p:cNvPr id="807643326" name="Rectangle 24"/>
+          <p:cNvPr id="623286688" name="Rectangle 24"/>
           <p:cNvSpPr/>
           <p:nvPr userDrawn="1"/>
         </p:nvSpPr>
@@ -12237,7 +12237,7 @@
       </p:sp>
       <p:sp>
         <p:nvSpPr>
-          <p:cNvPr id="1538027207" name="Rectangle 26"/>
+          <p:cNvPr id="1458082698" name="Rectangle 26"/>
           <p:cNvSpPr/>
           <p:nvPr userDrawn="1"/>
         </p:nvSpPr>
@@ -12261,7 +12261,7 @@
       </p:sp>
       <p:sp>
         <p:nvSpPr>
-          <p:cNvPr id="1030598906" name="Rectangle 27"/>
+          <p:cNvPr id="1106324973" name="Rectangle 27"/>
           <p:cNvSpPr/>
           <p:nvPr userDrawn="1"/>
         </p:nvSpPr>
@@ -12285,7 +12285,7 @@
       </p:sp>
       <p:sp>
         <p:nvSpPr>
-          <p:cNvPr id="2010825508" name="Rectangle 28"/>
+          <p:cNvPr id="504345889" name="Rectangle 28"/>
           <p:cNvSpPr/>
           <p:nvPr userDrawn="1"/>
         </p:nvSpPr>
@@ -12309,7 +12309,7 @@
       </p:sp>
       <p:sp>
         <p:nvSpPr>
-          <p:cNvPr id="789021321" name="Rectangle 25"/>
+          <p:cNvPr id="1979553249" name="Rectangle 25"/>
           <p:cNvSpPr/>
           <p:nvPr userDrawn="1"/>
         </p:nvSpPr>
@@ -12333,7 +12333,7 @@
       </p:sp>
       <p:sp>
         <p:nvSpPr>
-          <p:cNvPr id="2097131088" name="Rectangle 20"/>
+          <p:cNvPr id="304844501" name="Rectangle 20"/>
           <p:cNvSpPr/>
           <p:nvPr userDrawn="1"/>
         </p:nvSpPr>
@@ -12357,7 +12357,7 @@
       </p:sp>
       <p:sp>
         <p:nvSpPr>
-          <p:cNvPr id="422658999" name="Rectangle 43"/>
+          <p:cNvPr id="1135114212" name="Rectangle 43"/>
           <p:cNvSpPr/>
           <p:nvPr userDrawn="1"/>
         </p:nvSpPr>
@@ -12381,7 +12381,7 @@
       </p:sp>
       <p:sp>
         <p:nvSpPr>
-          <p:cNvPr id="360181808" name="Rectangle 45"/>
+          <p:cNvPr id="416287087" name="Rectangle 45"/>
           <p:cNvSpPr/>
           <p:nvPr userDrawn="1"/>
         </p:nvSpPr>
@@ -12405,7 +12405,7 @@
       </p:sp>
       <p:sp>
         <p:nvSpPr>
-          <p:cNvPr id="46720747" name="Rectangle 44"/>
+          <p:cNvPr id="660084713" name="Rectangle 44"/>
           <p:cNvSpPr/>
           <p:nvPr userDrawn="1"/>
         </p:nvSpPr>
@@ -12435,7 +12435,7 @@
       </p:sp>
       <p:sp>
         <p:nvSpPr>
-          <p:cNvPr id="1543268432" name="Subtitle 2"/>
+          <p:cNvPr id="1718052893" name="Subtitle 2"/>
           <p:cNvSpPr>
             <a:spLocks noGrp="1"/>
           </p:cNvSpPr>
@@ -12559,7 +12559,7 @@
       </p:sp>
       <p:sp>
         <p:nvSpPr>
-          <p:cNvPr id="1415336336" name="Title 9"/>
+          <p:cNvPr id="1820354139" name="Title 9"/>
           <p:cNvSpPr>
             <a:spLocks noGrp="1"/>
           </p:cNvSpPr>
@@ -12602,7 +12602,7 @@
       </p:sp>
       <p:cxnSp>
         <p:nvCxnSpPr>
-          <p:cNvPr id="1210503865" name="Прямая соединительная линия 48"/>
+          <p:cNvPr id="432040409" name="Прямая соединительная линия 48"/>
           <p:cNvCxnSpPr/>
           <p:nvPr userDrawn="1"/>
         </p:nvCxnSpPr>
@@ -12639,7 +12639,7 @@
       </p:cxnSp>
       <p:sp>
         <p:nvSpPr>
-          <p:cNvPr id="2059822624" name="Овал 50"/>
+          <p:cNvPr id="966912301" name="Овал 50"/>
           <p:cNvSpPr/>
           <p:nvPr userDrawn="1"/>
         </p:nvSpPr>
@@ -12662,7 +12662,7 @@
       </p:sp>
       <p:cxnSp>
         <p:nvCxnSpPr>
-          <p:cNvPr id="572592366" name="Прямая соединительная линия 53"/>
+          <p:cNvPr id="1157763842" name="Прямая соединительная линия 53"/>
           <p:cNvCxnSpPr/>
           <p:nvPr userDrawn="1"/>
         </p:nvCxnSpPr>
@@ -12699,7 +12699,7 @@
       </p:cxnSp>
       <p:sp>
         <p:nvSpPr>
-          <p:cNvPr id="1393870987" name="Date Placeholder 3"/>
+          <p:cNvPr id="465486984" name="Date Placeholder 3"/>
           <p:cNvSpPr>
             <a:spLocks noGrp="1"/>
           </p:cNvSpPr>
@@ -12725,7 +12725,7 @@
       </p:sp>
       <p:sp>
         <p:nvSpPr>
-          <p:cNvPr id="2105606146" name="Footer Placeholder 4"/>
+          <p:cNvPr id="733454573" name="Footer Placeholder 4"/>
           <p:cNvSpPr>
             <a:spLocks noGrp="1"/>
           </p:cNvSpPr>
@@ -12747,7 +12747,7 @@
       </p:sp>
       <p:sp>
         <p:nvSpPr>
-          <p:cNvPr id="2092077623" name="Slide Number Placeholder 5"/>
+          <p:cNvPr id="1946613432" name="Slide Number Placeholder 5"/>
           <p:cNvSpPr>
             <a:spLocks noGrp="1"/>
           </p:cNvSpPr>
@@ -12798,7 +12798,7 @@
       </p:grpSpPr>
       <p:sp>
         <p:nvSpPr>
-          <p:cNvPr id="948839851" name="Title 1"/>
+          <p:cNvPr id="1066943018" name="Title 1"/>
           <p:cNvSpPr>
             <a:spLocks noGrp="1"/>
           </p:cNvSpPr>
@@ -12824,7 +12824,7 @@
       </p:sp>
       <p:sp>
         <p:nvSpPr>
-          <p:cNvPr id="1930825001" name="Content Placeholder 2"/>
+          <p:cNvPr id="1645697867" name="Content Placeholder 2"/>
           <p:cNvSpPr>
             <a:spLocks noGrp="1"/>
           </p:cNvSpPr>
@@ -12890,7 +12890,7 @@
       </p:sp>
       <p:sp>
         <p:nvSpPr>
-          <p:cNvPr id="1141284359" name="Date Placeholder 3"/>
+          <p:cNvPr id="823245926" name="Date Placeholder 3"/>
           <p:cNvSpPr>
             <a:spLocks noGrp="1"/>
           </p:cNvSpPr>
@@ -12916,7 +12916,7 @@
       </p:sp>
       <p:sp>
         <p:nvSpPr>
-          <p:cNvPr id="474890717" name="Footer Placeholder 4"/>
+          <p:cNvPr id="1989918432" name="Footer Placeholder 4"/>
           <p:cNvSpPr>
             <a:spLocks noGrp="1"/>
           </p:cNvSpPr>
@@ -12938,7 +12938,7 @@
       </p:sp>
       <p:sp>
         <p:nvSpPr>
-          <p:cNvPr id="319182077" name="Slide Number Placeholder 5"/>
+          <p:cNvPr id="657740678" name="Slide Number Placeholder 5"/>
           <p:cNvSpPr>
             <a:spLocks noGrp="1"/>
           </p:cNvSpPr>
@@ -12989,7 +12989,7 @@
       </p:grpSpPr>
       <p:sp>
         <p:nvSpPr>
-          <p:cNvPr id="1847135819" name="Text Placeholder 2"/>
+          <p:cNvPr id="1162014304" name="Text Placeholder 2"/>
           <p:cNvSpPr>
             <a:spLocks noGrp="1"/>
           </p:cNvSpPr>
@@ -13111,7 +13111,7 @@
       </p:sp>
       <p:sp>
         <p:nvSpPr>
-          <p:cNvPr id="2145263779" name="Date Placeholder 3"/>
+          <p:cNvPr id="1671522478" name="Date Placeholder 3"/>
           <p:cNvSpPr>
             <a:spLocks noGrp="1"/>
           </p:cNvSpPr>
@@ -13137,7 +13137,7 @@
       </p:sp>
       <p:sp>
         <p:nvSpPr>
-          <p:cNvPr id="19940881" name="Footer Placeholder 4"/>
+          <p:cNvPr id="143377387" name="Footer Placeholder 4"/>
           <p:cNvSpPr>
             <a:spLocks noGrp="1"/>
           </p:cNvSpPr>
@@ -13159,7 +13159,7 @@
       </p:sp>
       <p:sp>
         <p:nvSpPr>
-          <p:cNvPr id="99974807" name="Slide Number Placeholder 5"/>
+          <p:cNvPr id="731351082" name="Slide Number Placeholder 5"/>
           <p:cNvSpPr>
             <a:spLocks noGrp="1"/>
           </p:cNvSpPr>
@@ -13185,7 +13185,7 @@
       </p:sp>
       <p:sp>
         <p:nvSpPr>
-          <p:cNvPr id="1637547902" name="Title 1"/>
+          <p:cNvPr id="481892996" name="Title 1"/>
           <p:cNvSpPr>
             <a:spLocks noGrp="1"/>
           </p:cNvSpPr>
@@ -13241,7 +13241,7 @@
       </p:grpSpPr>
       <p:sp>
         <p:nvSpPr>
-          <p:cNvPr id="1575994554" name="Title 1"/>
+          <p:cNvPr id="1908279745" name="Title 1"/>
           <p:cNvSpPr>
             <a:spLocks noGrp="1"/>
           </p:cNvSpPr>
@@ -13267,7 +13267,7 @@
       </p:sp>
       <p:sp>
         <p:nvSpPr>
-          <p:cNvPr id="1701799446" name="Content Placeholder 2"/>
+          <p:cNvPr id="1524202887" name="Content Placeholder 2"/>
           <p:cNvSpPr>
             <a:spLocks noGrp="1"/>
           </p:cNvSpPr>
@@ -13370,7 +13370,7 @@
       </p:sp>
       <p:sp>
         <p:nvSpPr>
-          <p:cNvPr id="2133935890" name="Content Placeholder 3"/>
+          <p:cNvPr id="253246303" name="Content Placeholder 3"/>
           <p:cNvSpPr>
             <a:spLocks noGrp="1"/>
           </p:cNvSpPr>
@@ -13473,7 +13473,7 @@
       </p:sp>
       <p:sp>
         <p:nvSpPr>
-          <p:cNvPr id="153463314" name="Date Placeholder 4"/>
+          <p:cNvPr id="242033470" name="Date Placeholder 4"/>
           <p:cNvSpPr>
             <a:spLocks noGrp="1"/>
           </p:cNvSpPr>
@@ -13499,7 +13499,7 @@
       </p:sp>
       <p:sp>
         <p:nvSpPr>
-          <p:cNvPr id="1675764665" name="Footer Placeholder 5"/>
+          <p:cNvPr id="2145539915" name="Footer Placeholder 5"/>
           <p:cNvSpPr>
             <a:spLocks noGrp="1"/>
           </p:cNvSpPr>
@@ -13521,7 +13521,7 @@
       </p:sp>
       <p:sp>
         <p:nvSpPr>
-          <p:cNvPr id="1679591128" name="Slide Number Placeholder 6"/>
+          <p:cNvPr id="1945473120" name="Slide Number Placeholder 6"/>
           <p:cNvSpPr>
             <a:spLocks noGrp="1"/>
           </p:cNvSpPr>
@@ -13572,7 +13572,7 @@
       </p:grpSpPr>
       <p:sp>
         <p:nvSpPr>
-          <p:cNvPr id="1738998835" name="Title 1"/>
+          <p:cNvPr id="336527338" name="Title 1"/>
           <p:cNvSpPr>
             <a:spLocks noGrp="1"/>
           </p:cNvSpPr>
@@ -13602,7 +13602,7 @@
       </p:sp>
       <p:sp>
         <p:nvSpPr>
-          <p:cNvPr id="1196766879" name="Text Placeholder 2"/>
+          <p:cNvPr id="1652319280" name="Text Placeholder 2"/>
           <p:cNvSpPr>
             <a:spLocks noGrp="1"/>
           </p:cNvSpPr>
@@ -13674,7 +13674,7 @@
       </p:sp>
       <p:sp>
         <p:nvSpPr>
-          <p:cNvPr id="1967073737" name="Content Placeholder 3"/>
+          <p:cNvPr id="1630671833" name="Content Placeholder 3"/>
           <p:cNvSpPr>
             <a:spLocks noGrp="1"/>
           </p:cNvSpPr>
@@ -13777,7 +13777,7 @@
       </p:sp>
       <p:sp>
         <p:nvSpPr>
-          <p:cNvPr id="1423978176" name="Text Placeholder 4"/>
+          <p:cNvPr id="39524393" name="Text Placeholder 4"/>
           <p:cNvSpPr>
             <a:spLocks noGrp="1"/>
           </p:cNvSpPr>
@@ -13849,7 +13849,7 @@
       </p:sp>
       <p:sp>
         <p:nvSpPr>
-          <p:cNvPr id="1824182280" name="Content Placeholder 5"/>
+          <p:cNvPr id="465325340" name="Content Placeholder 5"/>
           <p:cNvSpPr>
             <a:spLocks noGrp="1"/>
           </p:cNvSpPr>
@@ -13952,7 +13952,7 @@
       </p:sp>
       <p:sp>
         <p:nvSpPr>
-          <p:cNvPr id="1112722290" name="Date Placeholder 6"/>
+          <p:cNvPr id="1124704730" name="Date Placeholder 6"/>
           <p:cNvSpPr>
             <a:spLocks noGrp="1"/>
           </p:cNvSpPr>
@@ -13978,7 +13978,7 @@
       </p:sp>
       <p:sp>
         <p:nvSpPr>
-          <p:cNvPr id="1361033468" name="Footer Placeholder 7"/>
+          <p:cNvPr id="1024652634" name="Footer Placeholder 7"/>
           <p:cNvSpPr>
             <a:spLocks noGrp="1"/>
           </p:cNvSpPr>
@@ -14000,7 +14000,7 @@
       </p:sp>
       <p:sp>
         <p:nvSpPr>
-          <p:cNvPr id="1116615433" name="Slide Number Placeholder 8"/>
+          <p:cNvPr id="371017006" name="Slide Number Placeholder 8"/>
           <p:cNvSpPr>
             <a:spLocks noGrp="1"/>
           </p:cNvSpPr>
@@ -14051,7 +14051,7 @@
       </p:grpSpPr>
       <p:sp>
         <p:nvSpPr>
-          <p:cNvPr id="1608298259" name="Title 1"/>
+          <p:cNvPr id="1359097158" name="Title 1"/>
           <p:cNvSpPr>
             <a:spLocks noGrp="1"/>
           </p:cNvSpPr>
@@ -14077,7 +14077,7 @@
       </p:sp>
       <p:sp>
         <p:nvSpPr>
-          <p:cNvPr id="1266117154" name="Date Placeholder 2"/>
+          <p:cNvPr id="1024611525" name="Date Placeholder 2"/>
           <p:cNvSpPr>
             <a:spLocks noGrp="1"/>
           </p:cNvSpPr>
@@ -14103,7 +14103,7 @@
       </p:sp>
       <p:sp>
         <p:nvSpPr>
-          <p:cNvPr id="313256467" name="Footer Placeholder 3"/>
+          <p:cNvPr id="87944105" name="Footer Placeholder 3"/>
           <p:cNvSpPr>
             <a:spLocks noGrp="1"/>
           </p:cNvSpPr>
@@ -14125,7 +14125,7 @@
       </p:sp>
       <p:sp>
         <p:nvSpPr>
-          <p:cNvPr id="1057156642" name="Slide Number Placeholder 4"/>
+          <p:cNvPr id="158768713" name="Slide Number Placeholder 4"/>
           <p:cNvSpPr>
             <a:spLocks noGrp="1"/>
           </p:cNvSpPr>
@@ -14176,7 +14176,7 @@
       </p:grpSpPr>
       <p:sp>
         <p:nvSpPr>
-          <p:cNvPr id="1532849860" name="Date Placeholder 1"/>
+          <p:cNvPr id="418576141" name="Date Placeholder 1"/>
           <p:cNvSpPr>
             <a:spLocks noGrp="1"/>
           </p:cNvSpPr>
@@ -14202,7 +14202,7 @@
       </p:sp>
       <p:sp>
         <p:nvSpPr>
-          <p:cNvPr id="1654221991" name="Footer Placeholder 2"/>
+          <p:cNvPr id="1085192024" name="Footer Placeholder 2"/>
           <p:cNvSpPr>
             <a:spLocks noGrp="1"/>
           </p:cNvSpPr>
@@ -14224,7 +14224,7 @@
       </p:sp>
       <p:sp>
         <p:nvSpPr>
-          <p:cNvPr id="943530503" name="Slide Number Placeholder 3"/>
+          <p:cNvPr id="1075162087" name="Slide Number Placeholder 3"/>
           <p:cNvSpPr>
             <a:spLocks noGrp="1"/>
           </p:cNvSpPr>
@@ -14275,7 +14275,7 @@
       </p:grpSpPr>
       <p:sp>
         <p:nvSpPr>
-          <p:cNvPr id="829467757" name="Content Placeholder 2"/>
+          <p:cNvPr id="15451698" name="Content Placeholder 2"/>
           <p:cNvSpPr>
             <a:spLocks noGrp="1"/>
           </p:cNvSpPr>
@@ -14380,7 +14380,7 @@
       </p:sp>
       <p:sp>
         <p:nvSpPr>
-          <p:cNvPr id="2125849733" name="Text Placeholder 3"/>
+          <p:cNvPr id="1522585157" name="Text Placeholder 3"/>
           <p:cNvSpPr>
             <a:spLocks noGrp="1"/>
           </p:cNvSpPr>
@@ -14454,7 +14454,7 @@
       </p:sp>
       <p:sp>
         <p:nvSpPr>
-          <p:cNvPr id="1605724325" name="Date Placeholder 4"/>
+          <p:cNvPr id="171511854" name="Date Placeholder 4"/>
           <p:cNvSpPr>
             <a:spLocks noGrp="1"/>
           </p:cNvSpPr>
@@ -14480,7 +14480,7 @@
       </p:sp>
       <p:sp>
         <p:nvSpPr>
-          <p:cNvPr id="515524672" name="Footer Placeholder 5"/>
+          <p:cNvPr id="724573030" name="Footer Placeholder 5"/>
           <p:cNvSpPr>
             <a:spLocks noGrp="1"/>
           </p:cNvSpPr>
@@ -14502,7 +14502,7 @@
       </p:sp>
       <p:sp>
         <p:nvSpPr>
-          <p:cNvPr id="385376143" name="Slide Number Placeholder 6"/>
+          <p:cNvPr id="921005380" name="Slide Number Placeholder 6"/>
           <p:cNvSpPr>
             <a:spLocks noGrp="1"/>
           </p:cNvSpPr>
@@ -14528,7 +14528,7 @@
       </p:sp>
       <p:sp>
         <p:nvSpPr>
-          <p:cNvPr id="569492319" name="Title 1"/>
+          <p:cNvPr id="2009932636" name="Title 1"/>
           <p:cNvSpPr>
             <a:spLocks noGrp="1"/>
           </p:cNvSpPr>
@@ -14584,7 +14584,7 @@
       </p:grpSpPr>
       <p:sp>
         <p:nvSpPr>
-          <p:cNvPr id="913414721" name="Picture Placeholder 2"/>
+          <p:cNvPr id="1476631000" name="Picture Placeholder 2"/>
           <p:cNvSpPr>
             <a:spLocks noGrp="1"/>
           </p:cNvSpPr>
@@ -14652,7 +14652,7 @@
       </p:sp>
       <p:sp>
         <p:nvSpPr>
-          <p:cNvPr id="224303150" name="Text Placeholder 3"/>
+          <p:cNvPr id="1145204891" name="Text Placeholder 3"/>
           <p:cNvSpPr>
             <a:spLocks noGrp="1"/>
           </p:cNvSpPr>
@@ -14720,7 +14720,7 @@
       </p:sp>
       <p:sp>
         <p:nvSpPr>
-          <p:cNvPr id="839492790" name="Date Placeholder 4"/>
+          <p:cNvPr id="484434249" name="Date Placeholder 4"/>
           <p:cNvSpPr>
             <a:spLocks noGrp="1"/>
           </p:cNvSpPr>
@@ -14746,7 +14746,7 @@
       </p:sp>
       <p:sp>
         <p:nvSpPr>
-          <p:cNvPr id="1177779915" name="Footer Placeholder 5"/>
+          <p:cNvPr id="646003789" name="Footer Placeholder 5"/>
           <p:cNvSpPr>
             <a:spLocks noGrp="1"/>
           </p:cNvSpPr>
@@ -14768,7 +14768,7 @@
       </p:sp>
       <p:sp>
         <p:nvSpPr>
-          <p:cNvPr id="579925987" name="Slide Number Placeholder 6"/>
+          <p:cNvPr id="1521190763" name="Slide Number Placeholder 6"/>
           <p:cNvSpPr>
             <a:spLocks noGrp="1"/>
           </p:cNvSpPr>
@@ -14794,7 +14794,7 @@
       </p:sp>
       <p:sp>
         <p:nvSpPr>
-          <p:cNvPr id="1576580823" name="Title 1"/>
+          <p:cNvPr id="1455398124" name="Title 1"/>
           <p:cNvSpPr>
             <a:spLocks noGrp="1"/>
           </p:cNvSpPr>
@@ -14850,7 +14850,7 @@
       </p:grpSpPr>
       <p:sp>
         <p:nvSpPr>
-          <p:cNvPr id="1890731708" name="Google Shape;25;p54"/>
+          <p:cNvPr id="1410292394" name="Google Shape;25;p54"/>
           <p:cNvSpPr txBox="1">
             <a:spLocks noGrp="1"/>
           </p:cNvSpPr>
@@ -15013,7 +15013,7 @@
       </p:sp>
       <p:sp>
         <p:nvSpPr>
-          <p:cNvPr id="726463193" name="Google Shape;26;p54"/>
+          <p:cNvPr id="2128644062" name="Google Shape;26;p54"/>
           <p:cNvSpPr txBox="1">
             <a:spLocks noGrp="1"/>
           </p:cNvSpPr>
@@ -15176,7 +15176,7 @@
       </p:sp>
       <p:sp>
         <p:nvSpPr>
-          <p:cNvPr id="515850938" name="Google Shape;27;p54"/>
+          <p:cNvPr id="1287865274" name="Google Shape;27;p54"/>
           <p:cNvSpPr txBox="1">
             <a:spLocks noGrp="1"/>
           </p:cNvSpPr>
@@ -15474,7 +15474,7 @@
       </p:grpSpPr>
       <p:sp>
         <p:nvSpPr>
-          <p:cNvPr id="408090621" name="Title 1"/>
+          <p:cNvPr id="1636962836" name="Title 1"/>
           <p:cNvSpPr>
             <a:spLocks noGrp="1"/>
           </p:cNvSpPr>
@@ -15500,7 +15500,7 @@
       </p:sp>
       <p:sp>
         <p:nvSpPr>
-          <p:cNvPr id="1111336887" name="Vertical Text Placeholder 2"/>
+          <p:cNvPr id="1481415600" name="Vertical Text Placeholder 2"/>
           <p:cNvSpPr>
             <a:spLocks noGrp="1"/>
           </p:cNvSpPr>
@@ -15566,7 +15566,7 @@
       </p:sp>
       <p:sp>
         <p:nvSpPr>
-          <p:cNvPr id="542602217" name="Date Placeholder 3"/>
+          <p:cNvPr id="568925209" name="Date Placeholder 3"/>
           <p:cNvSpPr>
             <a:spLocks noGrp="1"/>
           </p:cNvSpPr>
@@ -15592,7 +15592,7 @@
       </p:sp>
       <p:sp>
         <p:nvSpPr>
-          <p:cNvPr id="1299667975" name="Footer Placeholder 4"/>
+          <p:cNvPr id="1480092344" name="Footer Placeholder 4"/>
           <p:cNvSpPr>
             <a:spLocks noGrp="1"/>
           </p:cNvSpPr>
@@ -15614,7 +15614,7 @@
       </p:sp>
       <p:sp>
         <p:nvSpPr>
-          <p:cNvPr id="173313212" name="Slide Number Placeholder 5"/>
+          <p:cNvPr id="2025709538" name="Slide Number Placeholder 5"/>
           <p:cNvSpPr>
             <a:spLocks noGrp="1"/>
           </p:cNvSpPr>
@@ -15665,7 +15665,7 @@
       </p:grpSpPr>
       <p:sp>
         <p:nvSpPr>
-          <p:cNvPr id="481728471" name="Vertical Title 1"/>
+          <p:cNvPr id="951078223" name="Vertical Title 1"/>
           <p:cNvSpPr>
             <a:spLocks noGrp="1"/>
           </p:cNvSpPr>
@@ -15696,7 +15696,7 @@
       </p:sp>
       <p:sp>
         <p:nvSpPr>
-          <p:cNvPr id="330658249" name="Vertical Text Placeholder 2"/>
+          <p:cNvPr id="454710118" name="Vertical Text Placeholder 2"/>
           <p:cNvSpPr>
             <a:spLocks noGrp="1"/>
           </p:cNvSpPr>
@@ -15767,7 +15767,7 @@
       </p:sp>
       <p:sp>
         <p:nvSpPr>
-          <p:cNvPr id="1901860068" name="Date Placeholder 3"/>
+          <p:cNvPr id="1172957654" name="Date Placeholder 3"/>
           <p:cNvSpPr>
             <a:spLocks noGrp="1"/>
           </p:cNvSpPr>
@@ -15793,7 +15793,7 @@
       </p:sp>
       <p:sp>
         <p:nvSpPr>
-          <p:cNvPr id="172454077" name="Footer Placeholder 4"/>
+          <p:cNvPr id="141859035" name="Footer Placeholder 4"/>
           <p:cNvSpPr>
             <a:spLocks noGrp="1"/>
           </p:cNvSpPr>
@@ -15815,7 +15815,7 @@
       </p:sp>
       <p:sp>
         <p:nvSpPr>
-          <p:cNvPr id="1821465418" name="Slide Number Placeholder 5"/>
+          <p:cNvPr id="1383598642" name="Slide Number Placeholder 5"/>
           <p:cNvSpPr>
             <a:spLocks noGrp="1"/>
           </p:cNvSpPr>
@@ -15866,7 +15866,7 @@
       </p:grpSpPr>
       <p:sp>
         <p:nvSpPr>
-          <p:cNvPr id="252890549" name="Google Shape;29;p55"/>
+          <p:cNvPr id="431847297" name="Google Shape;29;p55"/>
           <p:cNvSpPr txBox="1">
             <a:spLocks noGrp="1"/>
           </p:cNvSpPr>
@@ -16029,7 +16029,7 @@
       </p:sp>
       <p:sp>
         <p:nvSpPr>
-          <p:cNvPr id="1983479053" name="Google Shape;30;p55"/>
+          <p:cNvPr id="253052893" name="Google Shape;30;p55"/>
           <p:cNvSpPr txBox="1">
             <a:spLocks noGrp="1"/>
           </p:cNvSpPr>
@@ -16192,7 +16192,7 @@
       </p:sp>
       <p:sp>
         <p:nvSpPr>
-          <p:cNvPr id="1818829899" name="Google Shape;31;p55"/>
+          <p:cNvPr id="1207901423" name="Google Shape;31;p55"/>
           <p:cNvSpPr txBox="1">
             <a:spLocks noGrp="1"/>
           </p:cNvSpPr>
@@ -16490,7 +16490,7 @@
       </p:grpSpPr>
       <p:sp>
         <p:nvSpPr>
-          <p:cNvPr id="2081834268" name="Google Shape;33;p56"/>
+          <p:cNvPr id="1585227586" name="Google Shape;33;p56"/>
           <p:cNvSpPr txBox="1">
             <a:spLocks noGrp="1"/>
           </p:cNvSpPr>
@@ -16653,7 +16653,7 @@
       </p:sp>
       <p:sp>
         <p:nvSpPr>
-          <p:cNvPr id="1951167221" name="Google Shape;34;p56"/>
+          <p:cNvPr id="57262669" name="Google Shape;34;p56"/>
           <p:cNvSpPr txBox="1">
             <a:spLocks noGrp="1"/>
           </p:cNvSpPr>
@@ -16816,7 +16816,7 @@
       </p:sp>
       <p:sp>
         <p:nvSpPr>
-          <p:cNvPr id="797981508" name="Google Shape;35;p56"/>
+          <p:cNvPr id="1957953953" name="Google Shape;35;p56"/>
           <p:cNvSpPr txBox="1"/>
           <p:nvPr/>
         </p:nvSpPr>
@@ -16881,7 +16881,7 @@
       </p:sp>
       <p:sp>
         <p:nvSpPr>
-          <p:cNvPr id="106865506" name="Google Shape;36;p56"/>
+          <p:cNvPr id="741052265" name="Google Shape;36;p56"/>
           <p:cNvSpPr txBox="1">
             <a:spLocks noGrp="1"/>
           </p:cNvSpPr>
@@ -17186,7 +17186,7 @@
       </p:grpSpPr>
       <p:sp>
         <p:nvSpPr>
-          <p:cNvPr id="1687481024" name="Google Shape;38;p57"/>
+          <p:cNvPr id="224376805" name="Google Shape;38;p57"/>
           <p:cNvSpPr txBox="1">
             <a:spLocks noGrp="1"/>
           </p:cNvSpPr>
@@ -17349,7 +17349,7 @@
       </p:sp>
       <p:sp>
         <p:nvSpPr>
-          <p:cNvPr id="1226002502" name="Google Shape;39;p57"/>
+          <p:cNvPr id="1582702014" name="Google Shape;39;p57"/>
           <p:cNvSpPr txBox="1">
             <a:spLocks noGrp="1"/>
           </p:cNvSpPr>
@@ -17654,7 +17654,7 @@
       </p:grpSpPr>
       <p:sp>
         <p:nvSpPr>
-          <p:cNvPr id="1197728578" name="Google Shape;41;p58"/>
+          <p:cNvPr id="785186594" name="Google Shape;41;p58"/>
           <p:cNvSpPr txBox="1">
             <a:spLocks noGrp="1"/>
           </p:cNvSpPr>
@@ -17705,7 +17705,7 @@
       </p:sp>
       <p:sp>
         <p:nvSpPr>
-          <p:cNvPr id="882044076" name="Google Shape;42;p58"/>
+          <p:cNvPr id="679823425" name="Google Shape;42;p58"/>
           <p:cNvSpPr txBox="1">
             <a:spLocks noGrp="1"/>
           </p:cNvSpPr>
@@ -18010,7 +18010,7 @@
       </p:grpSpPr>
       <p:sp>
         <p:nvSpPr>
-          <p:cNvPr id="1332641542" name="Google Shape;44;p59"/>
+          <p:cNvPr id="28567999" name="Google Shape;44;p59"/>
           <p:cNvSpPr txBox="1">
             <a:spLocks noGrp="1"/>
           </p:cNvSpPr>
@@ -18315,7 +18315,7 @@
       </p:grpSpPr>
       <p:sp>
         <p:nvSpPr>
-          <p:cNvPr id="1785285674" name="Google Shape;6;p49"/>
+          <p:cNvPr id="1268066865" name="Google Shape;6;p49"/>
           <p:cNvSpPr txBox="1">
             <a:spLocks noGrp="1"/>
           </p:cNvSpPr>
@@ -18577,7 +18577,7 @@
       </p:sp>
       <p:sp>
         <p:nvSpPr>
-          <p:cNvPr id="1080295328" name="Google Shape;7;p49"/>
+          <p:cNvPr id="634438984" name="Google Shape;7;p49"/>
           <p:cNvSpPr txBox="1">
             <a:spLocks noGrp="1"/>
           </p:cNvSpPr>
@@ -18839,7 +18839,7 @@
       </p:sp>
       <p:sp>
         <p:nvSpPr>
-          <p:cNvPr id="1538575915" name="Google Shape;8;p49"/>
+          <p:cNvPr id="314980468" name="Google Shape;8;p49"/>
           <p:cNvSpPr txBox="1">
             <a:spLocks noGrp="1"/>
           </p:cNvSpPr>
@@ -19817,7 +19817,7 @@
       </p:grpSpPr>
       <p:sp>
         <p:nvSpPr>
-          <p:cNvPr id="1661890472" name="Google Shape;51;g320ca67c64f_0_409"/>
+          <p:cNvPr id="1495547385" name="Google Shape;51;g320ca67c64f_0_409"/>
           <p:cNvSpPr txBox="1">
             <a:spLocks noGrp="1"/>
           </p:cNvSpPr>
@@ -20052,7 +20052,7 @@
       </p:sp>
       <p:sp>
         <p:nvSpPr>
-          <p:cNvPr id="1520620095" name="Google Shape;52;g320ca67c64f_0_409"/>
+          <p:cNvPr id="753770126" name="Google Shape;52;g320ca67c64f_0_409"/>
           <p:cNvSpPr txBox="1">
             <a:spLocks noGrp="1"/>
           </p:cNvSpPr>
@@ -20314,7 +20314,7 @@
       </p:sp>
       <p:sp>
         <p:nvSpPr>
-          <p:cNvPr id="535269107" name="Google Shape;53;g320ca67c64f_0_409"/>
+          <p:cNvPr id="416651175" name="Google Shape;53;g320ca67c64f_0_409"/>
           <p:cNvSpPr txBox="1">
             <a:spLocks noGrp="1"/>
           </p:cNvSpPr>
@@ -21166,7 +21166,7 @@
       </p:grpSpPr>
       <p:sp>
         <p:nvSpPr>
-          <p:cNvPr id="253378306" name="Google Shape;6;p1"/>
+          <p:cNvPr id="1719812263" name="Google Shape;6;p1"/>
           <p:cNvSpPr txBox="1">
             <a:spLocks noGrp="1"/>
           </p:cNvSpPr>
@@ -21401,7 +21401,7 @@
       </p:sp>
       <p:sp>
         <p:nvSpPr>
-          <p:cNvPr id="1625863831" name="Google Shape;7;p1"/>
+          <p:cNvPr id="1341079644" name="Google Shape;7;p1"/>
           <p:cNvSpPr txBox="1">
             <a:spLocks noGrp="1"/>
           </p:cNvSpPr>
@@ -21663,7 +21663,7 @@
       </p:sp>
       <p:sp>
         <p:nvSpPr>
-          <p:cNvPr id="716690046" name="Google Shape;8;p1"/>
+          <p:cNvPr id="1056871349" name="Google Shape;8;p1"/>
           <p:cNvSpPr txBox="1">
             <a:spLocks noGrp="1"/>
           </p:cNvSpPr>
@@ -22518,7 +22518,7 @@
       </p:grpSpPr>
       <p:sp>
         <p:nvSpPr>
-          <p:cNvPr id="1656263693" name="Title Placeholder 1"/>
+          <p:cNvPr id="878452289" name="Title Placeholder 1"/>
           <p:cNvSpPr>
             <a:spLocks noGrp="1"/>
           </p:cNvSpPr>
@@ -22550,7 +22550,7 @@
       </p:sp>
       <p:sp>
         <p:nvSpPr>
-          <p:cNvPr id="183818244" name="Text Placeholder 2"/>
+          <p:cNvPr id="1212236457" name="Text Placeholder 2"/>
           <p:cNvSpPr>
             <a:spLocks noGrp="1"/>
           </p:cNvSpPr>
@@ -22631,7 +22631,7 @@
       </p:sp>
       <p:sp>
         <p:nvSpPr>
-          <p:cNvPr id="342424932" name="Date Placeholder 3"/>
+          <p:cNvPr id="554443261" name="Date Placeholder 3"/>
           <p:cNvSpPr>
             <a:spLocks noGrp="1"/>
           </p:cNvSpPr>
@@ -22673,7 +22673,7 @@
       </p:sp>
       <p:sp>
         <p:nvSpPr>
-          <p:cNvPr id="878622540" name="Footer Placeholder 4"/>
+          <p:cNvPr id="1556129537" name="Footer Placeholder 4"/>
           <p:cNvSpPr>
             <a:spLocks noGrp="1"/>
           </p:cNvSpPr>
@@ -22711,7 +22711,7 @@
       </p:sp>
       <p:sp>
         <p:nvSpPr>
-          <p:cNvPr id="313473290" name="Slide Number Placeholder 8"/>
+          <p:cNvPr id="848535418" name="Slide Number Placeholder 8"/>
           <p:cNvSpPr>
             <a:spLocks noGrp="1"/>
           </p:cNvSpPr>
@@ -23085,7 +23085,7 @@
       </p:grpSpPr>
       <p:sp>
         <p:nvSpPr>
-          <p:cNvPr id="493174346" name="Google Shape;107;p2"/>
+          <p:cNvPr id="1462661793" name="Google Shape;107;p2"/>
           <p:cNvSpPr txBox="1">
             <a:spLocks noGrp="1"/>
           </p:cNvSpPr>
@@ -23150,7 +23150,7 @@
       </p:sp>
       <p:sp>
         <p:nvSpPr>
-          <p:cNvPr id="1498260574" name="Google Shape;108;p2"/>
+          <p:cNvPr id="1655310301" name="Google Shape;108;p2"/>
           <p:cNvSpPr txBox="1">
             <a:spLocks noGrp="1"/>
           </p:cNvSpPr>
@@ -23201,7 +23201,7 @@
       </p:sp>
       <p:pic>
         <p:nvPicPr>
-          <p:cNvPr id="1860734032" name="Google Shape;109;p2" descr="Logo for &quot;Cascadia College, in Bothell&quot;" title="Logo for &quot;Cascadia College, in Bothell&quot;"/>
+          <p:cNvPr id="1405460280" name="Google Shape;109;p2" descr="Logo for &quot;Cascadia College, in Bothell&quot;" title="Logo for &quot;Cascadia College, in Bothell&quot;"/>
           <p:cNvPicPr/>
           <p:nvPr/>
         </p:nvPicPr>
@@ -23227,7 +23227,7 @@
       </p:pic>
       <p:pic>
         <p:nvPicPr>
-          <p:cNvPr id="126230612" name="Logo for the Java programming language" descr="Logo for the Java programming language" title="Logo for the Java programming language"/>
+          <p:cNvPr id="781112905" name="Logo for the Java programming language" descr="Logo for the Java programming language" title="Logo for the Java programming language"/>
           <p:cNvPicPr/>
           <p:nvPr/>
         </p:nvPicPr>
@@ -23253,7 +23253,7 @@
       </p:pic>
       <p:sp>
         <p:nvSpPr>
-          <p:cNvPr id="2059916874" name="Google Shape;111;p2"/>
+          <p:cNvPr id="425421208" name="Google Shape;111;p2"/>
           <p:cNvSpPr txBox="1">
             <a:spLocks noGrp="1"/>
           </p:cNvSpPr>
@@ -23337,7 +23337,7 @@
       </p:grpSpPr>
       <p:sp>
         <p:nvSpPr>
-          <p:cNvPr id="309156581" name="Title 1"/>
+          <p:cNvPr id="1967296390" name="Title 1"/>
           <p:cNvSpPr>
             <a:spLocks noGrp="1"/>
           </p:cNvSpPr>
@@ -23368,7 +23368,7 @@
       </p:sp>
       <p:sp>
         <p:nvSpPr>
-          <p:cNvPr id="719172185" name="Text Placeholder 2"/>
+          <p:cNvPr id="811561252" name="Text Placeholder 2"/>
           <p:cNvSpPr>
             <a:spLocks noGrp="1"/>
           </p:cNvSpPr>
@@ -23436,7 +23436,7 @@
       </p:sp>
       <p:sp>
         <p:nvSpPr>
-          <p:cNvPr id="2087128941" name="Slide Number Placeholder 3"/>
+          <p:cNvPr id="308191903" name="Slide Number Placeholder 3"/>
           <p:cNvSpPr>
             <a:spLocks noGrp="1"/>
           </p:cNvSpPr>
@@ -23509,7 +23509,7 @@
       </p:grpSpPr>
       <p:sp>
         <p:nvSpPr>
-          <p:cNvPr id="2062282319" name="Google Shape;515;g32a7fc5f463_1_0"/>
+          <p:cNvPr id="97673476" name="Google Shape;515;g32a7fc5f463_1_0"/>
           <p:cNvSpPr txBox="1">
             <a:spLocks noGrp="1"/>
           </p:cNvSpPr>
@@ -23560,7 +23560,7 @@
       </p:sp>
       <p:sp>
         <p:nvSpPr>
-          <p:cNvPr id="1166901506" name="Google Shape;516;g32a7fc5f463_1_0"/>
+          <p:cNvPr id="2092914319" name="Google Shape;516;g32a7fc5f463_1_0"/>
           <p:cNvSpPr txBox="1">
             <a:spLocks noGrp="1"/>
           </p:cNvSpPr>
@@ -23649,6 +23649,10 @@
               <a:rPr lang="en-US"/>
               <a:t> before you submit.</a:t>
             </a:r>
+            <a:r>
+              <a:rPr/>
+              <a:t> </a:t>
+            </a:r>
             <a:endParaRPr/>
           </a:p>
           <a:p>
@@ -23797,7 +23801,7 @@
       </p:sp>
       <p:sp>
         <p:nvSpPr>
-          <p:cNvPr id="1572659985" name="Google Shape;517;g32a7fc5f463_1_0"/>
+          <p:cNvPr id="1935487864" name="Google Shape;517;g32a7fc5f463_1_0"/>
           <p:cNvSpPr txBox="1">
             <a:spLocks noGrp="1"/>
           </p:cNvSpPr>
@@ -23849,7 +23853,7 @@
       </p:sp>
       <p:pic>
         <p:nvPicPr>
-          <p:cNvPr id="2104993391" name="Google Shape;518;g32a7fc5f463_1_0" descr="Decorative image of adorable animal saying &quot;Bye Bye&quot;" title="Decorative image of adorable animal saying &quot;Bye Bye&quot;"/>
+          <p:cNvPr id="1057922390" name="Google Shape;518;g32a7fc5f463_1_0" descr="Decorative image of adorable animal saying &quot;Bye Bye&quot;" title="Decorative image of adorable animal saying &quot;Bye Bye&quot;"/>
           <p:cNvPicPr/>
           <p:nvPr/>
         </p:nvPicPr>
@@ -23908,7 +23912,7 @@
       </p:grpSpPr>
       <p:sp>
         <p:nvSpPr>
-          <p:cNvPr id="1377745746" name="Google Shape;128;p4"/>
+          <p:cNvPr id="1219907854" name="Google Shape;128;p4"/>
           <p:cNvSpPr txBox="1">
             <a:spLocks noGrp="1"/>
           </p:cNvSpPr>
@@ -23959,7 +23963,7 @@
       </p:sp>
       <p:sp>
         <p:nvSpPr>
-          <p:cNvPr id="930134212" name="Google Shape;129;p4"/>
+          <p:cNvPr id="442932796" name="Google Shape;129;p4"/>
           <p:cNvSpPr txBox="1">
             <a:spLocks noGrp="1"/>
           </p:cNvSpPr>
@@ -24153,7 +24157,7 @@
       </p:sp>
       <p:sp>
         <p:nvSpPr>
-          <p:cNvPr id="752645093" name="Google Shape;130;p4"/>
+          <p:cNvPr id="354152162" name="Google Shape;130;p4"/>
           <p:cNvSpPr txBox="1">
             <a:spLocks noGrp="1"/>
           </p:cNvSpPr>
@@ -24237,7 +24241,7 @@
       </p:grpSpPr>
       <p:sp>
         <p:nvSpPr>
-          <p:cNvPr id="547525302" name="Google Shape;135;p5"/>
+          <p:cNvPr id="999458429" name="Google Shape;135;p5"/>
           <p:cNvSpPr txBox="1">
             <a:spLocks noGrp="1"/>
           </p:cNvSpPr>
@@ -24288,7 +24292,7 @@
       </p:sp>
       <p:sp>
         <p:nvSpPr>
-          <p:cNvPr id="1958905574" name="Google Shape;136;p5"/>
+          <p:cNvPr id="1920183191" name="Google Shape;136;p5"/>
           <p:cNvSpPr txBox="1">
             <a:spLocks noGrp="1"/>
           </p:cNvSpPr>
@@ -24536,7 +24540,7 @@
       </p:sp>
       <p:sp>
         <p:nvSpPr>
-          <p:cNvPr id="1796625816" name="Google Shape;137;p5"/>
+          <p:cNvPr id="1112394754" name="Google Shape;137;p5"/>
           <p:cNvSpPr txBox="1">
             <a:spLocks noGrp="1"/>
           </p:cNvSpPr>
@@ -24620,7 +24624,7 @@
       </p:grpSpPr>
       <p:sp>
         <p:nvSpPr>
-          <p:cNvPr id="1178489882" name="Google Shape;143;p6"/>
+          <p:cNvPr id="309659015" name="Google Shape;143;p6"/>
           <p:cNvSpPr txBox="1">
             <a:spLocks noGrp="1"/>
           </p:cNvSpPr>
@@ -24671,7 +24675,7 @@
       </p:sp>
       <p:sp>
         <p:nvSpPr>
-          <p:cNvPr id="713983725" name="Google Shape;144;p6"/>
+          <p:cNvPr id="697611042" name="Google Shape;144;p6"/>
           <p:cNvSpPr/>
           <p:nvPr/>
         </p:nvSpPr>
@@ -24735,7 +24739,7 @@
       </p:sp>
       <p:grpSp>
         <p:nvGrpSpPr>
-          <p:cNvPr id="1699421922" name="Google Shape;145;p6" descr="IT-CS 115: Vocabulary&#10;- Methods&#10;- Control Structures&#10;- Data Types&#10;"/>
+          <p:cNvPr id="1896575344" name="Google Shape;145;p6" descr="IT-CS 115: Vocabulary&#10;- Methods&#10;- Control Structures&#10;- Data Types&#10;"/>
           <p:cNvGrpSpPr/>
           <p:nvPr/>
         </p:nvGrpSpPr>
@@ -25083,7 +25087,7 @@
       </p:grpSp>
       <p:grpSp>
         <p:nvGrpSpPr>
-          <p:cNvPr id="526528892" name="Google Shape;150;p6" descr="IT-CS 142: Grammar&#10;- Using Data Structures&#10;- Object-Oriented Programming&#10;"/>
+          <p:cNvPr id="1452086972" name="Google Shape;150;p6" descr="IT-CS 142: Grammar&#10;- Using Data Structures&#10;- Object-Oriented Programming&#10;"/>
           <p:cNvGrpSpPr/>
           <p:nvPr/>
         </p:nvGrpSpPr>
@@ -25420,7 +25424,7 @@
       </p:grpSp>
       <p:grpSp>
         <p:nvGrpSpPr>
-          <p:cNvPr id="1150406422" name="Google Shape;155;p6" descr="IT-CS 143: Structured Writing&#10;- Object Design&#10;- Data Abstraction&#10;- Algorithms&#10;"/>
+          <p:cNvPr id="1823089870" name="Google Shape;155;p6" descr="IT-CS 143: Structured Writing&#10;- Object Design&#10;- Data Abstraction&#10;- Algorithms&#10;"/>
           <p:cNvGrpSpPr/>
           <p:nvPr/>
         </p:nvGrpSpPr>
@@ -25818,7 +25822,7 @@
       </p:grpSp>
       <p:grpSp>
         <p:nvGrpSpPr>
-          <p:cNvPr id="1511100581" name="Google Shape;160;p6" descr="IT-CS 265:&#10;- Data Structure Design and Implementation&#10;- Algorithmic Design&#10;- Code Analysis&#10;"/>
+          <p:cNvPr id="1191079086" name="Google Shape;160;p6" descr="IT-CS 265:&#10;- Data Structure Design and Implementation&#10;- Algorithmic Design&#10;- Code Analysis&#10;"/>
           <p:cNvGrpSpPr/>
           <p:nvPr/>
         </p:nvGrpSpPr>
@@ -26216,7 +26220,7 @@
       </p:grpSp>
       <p:sp>
         <p:nvSpPr>
-          <p:cNvPr id="1024595690" name="Google Shape;165;p6"/>
+          <p:cNvPr id="1109968721" name="Google Shape;165;p6"/>
           <p:cNvSpPr/>
           <p:nvPr/>
         </p:nvSpPr>
@@ -26280,7 +26284,7 @@
       </p:sp>
       <p:sp>
         <p:nvSpPr>
-          <p:cNvPr id="29775094" name="Google Shape;166;p6"/>
+          <p:cNvPr id="636731601" name="Google Shape;166;p6"/>
           <p:cNvSpPr/>
           <p:nvPr/>
         </p:nvSpPr>
@@ -26344,7 +26348,7 @@
       </p:sp>
       <p:sp>
         <p:nvSpPr>
-          <p:cNvPr id="1743748059" name="Google Shape;167;p6"/>
+          <p:cNvPr id="1517289390" name="Google Shape;167;p6"/>
           <p:cNvSpPr/>
           <p:nvPr/>
         </p:nvSpPr>
@@ -26408,7 +26412,7 @@
       </p:sp>
       <p:sp>
         <p:nvSpPr>
-          <p:cNvPr id="1504017543" name="Google Shape;168;p6"/>
+          <p:cNvPr id="190991104" name="Google Shape;168;p6"/>
           <p:cNvSpPr/>
           <p:nvPr/>
         </p:nvSpPr>
@@ -26472,7 +26476,7 @@
       </p:sp>
       <p:sp>
         <p:nvSpPr>
-          <p:cNvPr id="104850976" name="Google Shape;169;p6"/>
+          <p:cNvPr id="1467745646" name="Google Shape;169;p6"/>
           <p:cNvSpPr/>
           <p:nvPr/>
         </p:nvSpPr>
@@ -26536,7 +26540,7 @@
       </p:sp>
       <p:sp>
         <p:nvSpPr>
-          <p:cNvPr id="964665833" name="Google Shape;170;p6"/>
+          <p:cNvPr id="1861099502" name="Google Shape;170;p6"/>
           <p:cNvSpPr txBox="1"/>
           <p:nvPr/>
         </p:nvSpPr>
@@ -26601,7 +26605,7 @@
       </p:sp>
       <p:sp>
         <p:nvSpPr>
-          <p:cNvPr id="331926724" name="Google Shape;172;p6"/>
+          <p:cNvPr id="127801629" name="Google Shape;172;p6"/>
           <p:cNvSpPr txBox="1"/>
           <p:nvPr/>
         </p:nvSpPr>
@@ -27056,7 +27060,7 @@
       </p:sp>
       <p:sp>
         <p:nvSpPr>
-          <p:cNvPr id="1652911864" name="Google Shape;171;p6"/>
+          <p:cNvPr id="366665753" name="Google Shape;171;p6"/>
           <p:cNvSpPr txBox="1"/>
           <p:nvPr/>
         </p:nvSpPr>
@@ -27121,7 +27125,7 @@
       </p:sp>
       <p:sp>
         <p:nvSpPr>
-          <p:cNvPr id="1541565030" name="Google Shape;173;p6"/>
+          <p:cNvPr id="2046098225" name="Google Shape;173;p6"/>
           <p:cNvSpPr txBox="1">
             <a:spLocks noGrp="1"/>
           </p:cNvSpPr>
@@ -27217,7 +27221,7 @@
                                           </p:stCondLst>
                                         </p:cTn>
                                         <p:tgtEl>
-                                          <p:spTgt spid="713983725"/>
+                                          <p:spTgt spid="697611042"/>
                                         </p:tgtEl>
                                         <p:attrNameLst>
                                           <p:attrName>style.visibility</p:attrName>
@@ -27244,7 +27248,7 @@
                                           </p:stCondLst>
                                         </p:cTn>
                                         <p:tgtEl>
-                                          <p:spTgt spid="526528892"/>
+                                          <p:spTgt spid="1452086972"/>
                                         </p:tgtEl>
                                         <p:attrNameLst>
                                           <p:attrName>style.visibility</p:attrName>
@@ -27289,7 +27293,7 @@
                                           </p:stCondLst>
                                         </p:cTn>
                                         <p:tgtEl>
-                                          <p:spTgt spid="1024595690"/>
+                                          <p:spTgt spid="1109968721"/>
                                         </p:tgtEl>
                                         <p:attrNameLst>
                                           <p:attrName>style.visibility</p:attrName>
@@ -27316,7 +27320,7 @@
                                           </p:stCondLst>
                                         </p:cTn>
                                         <p:tgtEl>
-                                          <p:spTgt spid="1150406422"/>
+                                          <p:spTgt spid="1823089870"/>
                                         </p:tgtEl>
                                         <p:attrNameLst>
                                           <p:attrName>style.visibility</p:attrName>
@@ -27361,7 +27365,7 @@
                                           </p:stCondLst>
                                         </p:cTn>
                                         <p:tgtEl>
-                                          <p:spTgt spid="29775094"/>
+                                          <p:spTgt spid="636731601"/>
                                         </p:tgtEl>
                                         <p:attrNameLst>
                                           <p:attrName>style.visibility</p:attrName>
@@ -27388,7 +27392,7 @@
                                           </p:stCondLst>
                                         </p:cTn>
                                         <p:tgtEl>
-                                          <p:spTgt spid="1511100581"/>
+                                          <p:spTgt spid="1191079086"/>
                                         </p:tgtEl>
                                         <p:attrNameLst>
                                           <p:attrName>style.visibility</p:attrName>
@@ -27433,7 +27437,7 @@
                                           </p:stCondLst>
                                         </p:cTn>
                                         <p:tgtEl>
-                                          <p:spTgt spid="1743748059"/>
+                                          <p:spTgt spid="1517289390"/>
                                         </p:tgtEl>
                                         <p:attrNameLst>
                                           <p:attrName>style.visibility</p:attrName>
@@ -27460,7 +27464,7 @@
                                           </p:stCondLst>
                                         </p:cTn>
                                         <p:tgtEl>
-                                          <p:spTgt spid="1504017543"/>
+                                          <p:spTgt spid="190991104"/>
                                         </p:tgtEl>
                                         <p:attrNameLst>
                                           <p:attrName>style.visibility</p:attrName>
@@ -27487,7 +27491,7 @@
                                           </p:stCondLst>
                                         </p:cTn>
                                         <p:tgtEl>
-                                          <p:spTgt spid="104850976"/>
+                                          <p:spTgt spid="1467745646"/>
                                         </p:tgtEl>
                                         <p:attrNameLst>
                                           <p:attrName>style.visibility</p:attrName>
@@ -27514,7 +27518,7 @@
                                           </p:stCondLst>
                                         </p:cTn>
                                         <p:tgtEl>
-                                          <p:spTgt spid="964665833"/>
+                                          <p:spTgt spid="1861099502"/>
                                         </p:tgtEl>
                                         <p:attrNameLst>
                                           <p:attrName>style.visibility</p:attrName>
@@ -27577,7 +27581,7 @@
       </p:grpSpPr>
       <p:sp>
         <p:nvSpPr>
-          <p:cNvPr id="330316532" name="Google Shape;178;g320ca67c64f_0_233"/>
+          <p:cNvPr id="2044076280" name="Google Shape;178;g320ca67c64f_0_233"/>
           <p:cNvSpPr txBox="1">
             <a:spLocks noGrp="1"/>
           </p:cNvSpPr>
@@ -27620,7 +27624,7 @@
       </p:sp>
       <p:sp>
         <p:nvSpPr>
-          <p:cNvPr id="1291550158" name="Google Shape;179;g320ca67c64f_0_233"/>
+          <p:cNvPr id="1593003330" name="Google Shape;179;g320ca67c64f_0_233"/>
           <p:cNvSpPr txBox="1">
             <a:spLocks noGrp="1"/>
           </p:cNvSpPr>
@@ -27756,7 +27760,7 @@
       </p:sp>
       <p:sp>
         <p:nvSpPr>
-          <p:cNvPr id="586471231" name="Google Shape;180;g320ca67c64f_0_233"/>
+          <p:cNvPr id="1423813159" name="Google Shape;180;g320ca67c64f_0_233"/>
           <p:cNvSpPr txBox="1">
             <a:spLocks noGrp="1"/>
           </p:cNvSpPr>
@@ -27832,7 +27836,7 @@
       </p:grpSpPr>
       <p:sp>
         <p:nvSpPr>
-          <p:cNvPr id="401307443" name="Google Shape;208;g320ca67c64f_0_259"/>
+          <p:cNvPr id="261256637" name="Google Shape;208;g320ca67c64f_0_259"/>
           <p:cNvSpPr txBox="1">
             <a:spLocks noGrp="1"/>
           </p:cNvSpPr>
@@ -27875,7 +27879,7 @@
       </p:sp>
       <p:sp>
         <p:nvSpPr>
-          <p:cNvPr id="371504139" name="Google Shape;209;g320ca67c64f_0_259"/>
+          <p:cNvPr id="1994425653" name="Google Shape;209;g320ca67c64f_0_259"/>
           <p:cNvSpPr txBox="1">
             <a:spLocks noGrp="1"/>
           </p:cNvSpPr>
@@ -28163,7 +28167,7 @@
       </p:sp>
       <p:sp>
         <p:nvSpPr>
-          <p:cNvPr id="249079686" name="Google Shape;210;g320ca67c64f_0_259"/>
+          <p:cNvPr id="2105992470" name="Google Shape;210;g320ca67c64f_0_259"/>
           <p:cNvSpPr txBox="1">
             <a:spLocks noGrp="1"/>
           </p:cNvSpPr>
@@ -28239,7 +28243,7 @@
       </p:grpSpPr>
       <p:sp>
         <p:nvSpPr>
-          <p:cNvPr id="1353238611" name="Google Shape;215;g320ca67c64f_0_265"/>
+          <p:cNvPr id="271889940" name="Google Shape;215;g320ca67c64f_0_265"/>
           <p:cNvSpPr txBox="1">
             <a:spLocks noGrp="1"/>
           </p:cNvSpPr>
@@ -28282,7 +28286,7 @@
       </p:sp>
       <p:sp>
         <p:nvSpPr>
-          <p:cNvPr id="938605179" name="Google Shape;216;g320ca67c64f_0_265"/>
+          <p:cNvPr id="121200145" name="Google Shape;216;g320ca67c64f_0_265"/>
           <p:cNvSpPr txBox="1">
             <a:spLocks noGrp="1"/>
           </p:cNvSpPr>
@@ -28393,7 +28397,7 @@
       </p:sp>
       <p:pic>
         <p:nvPicPr>
-          <p:cNvPr id="1549180779" name="Google Shape;218;g320ca67c64f_0_265" descr="Click on Account on the left-hand bar of Canvas. Then click on Notifications."/>
+          <p:cNvPr id="1131198451" name="Google Shape;218;g320ca67c64f_0_265" descr="Click on Account on the left-hand bar of Canvas. Then click on Notifications."/>
           <p:cNvPicPr/>
           <p:nvPr/>
         </p:nvPicPr>
@@ -28419,7 +28423,7 @@
       </p:pic>
       <p:pic>
         <p:nvPicPr>
-          <p:cNvPr id="1878968825" name="Google Shape;219;g320ca67c64f_0_265" descr="Within notification settings. Adjust the push notifications and email options for due date, announcement, and grading."/>
+          <p:cNvPr id="1462183269" name="Google Shape;219;g320ca67c64f_0_265" descr="Within notification settings. Adjust the push notifications and email options for due date, announcement, and grading."/>
           <p:cNvPicPr/>
           <p:nvPr/>
         </p:nvPicPr>
@@ -28445,7 +28449,7 @@
       </p:pic>
       <p:sp>
         <p:nvSpPr>
-          <p:cNvPr id="502325881" name="Google Shape;217;g320ca67c64f_0_265"/>
+          <p:cNvPr id="265957314" name="Google Shape;217;g320ca67c64f_0_265"/>
           <p:cNvSpPr txBox="1">
             <a:spLocks noGrp="1"/>
           </p:cNvSpPr>
@@ -28521,7 +28525,7 @@
       </p:grpSpPr>
       <p:sp>
         <p:nvSpPr>
-          <p:cNvPr id="624323210" name="Google Shape;177;p25"/>
+          <p:cNvPr id="962435255" name="Google Shape;177;p25"/>
           <p:cNvSpPr txBox="1">
             <a:spLocks noGrp="1"/>
           </p:cNvSpPr>
@@ -28564,7 +28568,7 @@
       </p:sp>
       <p:sp>
         <p:nvSpPr>
-          <p:cNvPr id="1709855277" name="Google Shape;178;p25"/>
+          <p:cNvPr id="1976800891" name="Google Shape;178;p25"/>
           <p:cNvSpPr txBox="1">
             <a:spLocks noGrp="1"/>
           </p:cNvSpPr>
@@ -28815,7 +28819,7 @@
       </p:sp>
       <p:sp>
         <p:nvSpPr>
-          <p:cNvPr id="1679764739" name="Google Shape;179;p25"/>
+          <p:cNvPr id="449685281" name="Google Shape;179;p25"/>
           <p:cNvSpPr txBox="1">
             <a:spLocks noGrp="1"/>
           </p:cNvSpPr>
@@ -28915,7 +28919,7 @@
       </p:grpSpPr>
       <p:sp>
         <p:nvSpPr>
-          <p:cNvPr id="1620609265" name="Title 1"/>
+          <p:cNvPr id="139656363" name="Title 1"/>
           <p:cNvSpPr>
             <a:spLocks noGrp="1"/>
           </p:cNvSpPr>
@@ -28941,7 +28945,7 @@
       </p:sp>
       <p:sp>
         <p:nvSpPr>
-          <p:cNvPr id="799728541" name="Slide Number Placeholder 2"/>
+          <p:cNvPr id="923895804" name="Slide Number Placeholder 2"/>
           <p:cNvSpPr>
             <a:spLocks noGrp="1"/>
           </p:cNvSpPr>

</xml_diff>